<commit_message>
Recast the ELDA one-pager as a capability brief
Opens on the operational outcome rather than the course description, and
names the Leadership Development Plan in the first paragraph. Adds the
rationale for why the method works and a credibility statement for the
Leadership Centre. The aim is rewritten around performing, adapting and
influencing under pressure; educational phrasing gives way to behavioural
and command language; and the close is an offer to tailor a serial rather
than a list of next steps.

Co-Authored-By: Claude Fable 5 <noreply@anthropic.com>
Claude-Session: https://claude.ai/code/session_01YLo1WfwUDkbwfJEF3ZNVbB
</commit_message>
<xml_diff>
--- a/output/elda-command-onepager.pptx
+++ b/output/elda-command-onepager.pptx
@@ -907,7 +907,7 @@
         </p:nvSpPr>
         <p:spPr>
           <a:xfrm>
-            <a:off x="457200" y="822960"/>
+            <a:off x="457200" y="804672"/>
             <a:ext cx="6647688" cy="384048"/>
           </a:xfrm>
           <a:prstGeom prst="rect">
@@ -946,7 +946,7 @@
         </p:nvSpPr>
         <p:spPr>
           <a:xfrm>
-            <a:off x="457200" y="1188720"/>
+            <a:off x="457200" y="1170432"/>
             <a:ext cx="6647688" cy="201168"/>
           </a:xfrm>
           <a:prstGeom prst="rect">
@@ -985,8 +985,8 @@
         </p:nvSpPr>
         <p:spPr>
           <a:xfrm>
-            <a:off x="457200" y="1389888"/>
-            <a:ext cx="6647688" cy="182880"/>
+            <a:off x="457200" y="1371600"/>
+            <a:ext cx="5184648" cy="182880"/>
           </a:xfrm>
           <a:prstGeom prst="rect">
             <a:avLst/>
@@ -1018,13 +1018,52 @@
       </p:sp>
       <p:sp>
         <p:nvSpPr>
-          <p:cNvPr id="6" name="Shape 3"/>
-          <p:cNvSpPr/>
-          <p:nvPr/>
-        </p:nvSpPr>
-        <p:spPr>
-          <a:xfrm>
-            <a:off x="457200" y="1627632"/>
+          <p:cNvPr id="6" name="Text 3"/>
+          <p:cNvSpPr/>
+          <p:nvPr/>
+        </p:nvSpPr>
+        <p:spPr>
+          <a:xfrm>
+            <a:off x="5641848" y="1371600"/>
+            <a:ext cx="1463040" cy="182880"/>
+          </a:xfrm>
+          <a:prstGeom prst="rect">
+            <a:avLst/>
+          </a:prstGeom>
+          <a:noFill/>
+          <a:ln/>
+        </p:spPr>
+        <p:txBody>
+          <a:bodyPr wrap="square" lIns="0" tIns="0" rIns="0" bIns="0" rtlCol="0" anchor="ctr"/>
+          <a:lstStyle/>
+          <a:p>
+            <a:pPr algn="r" indent="0" marL="0">
+              <a:buNone/>
+            </a:pPr>
+            <a:r>
+              <a:rPr lang="en-US" sz="850" dirty="0">
+                <a:solidFill>
+                  <a:srgbClr val="7F7F7F"/>
+                </a:solidFill>
+                <a:latin typeface="Arial" pitchFamily="34" charset="0"/>
+                <a:ea typeface="Arial" pitchFamily="34" charset="-122"/>
+                <a:cs typeface="Arial" pitchFamily="34" charset="-120"/>
+              </a:rPr>
+              <a:t>August 2026</a:t>
+            </a:r>
+            <a:endParaRPr lang="en-US" sz="850" dirty="0"/>
+          </a:p>
+        </p:txBody>
+      </p:sp>
+      <p:sp>
+        <p:nvSpPr>
+          <p:cNvPr id="7" name="Shape 4"/>
+          <p:cNvSpPr/>
+          <p:nvPr/>
+        </p:nvSpPr>
+        <p:spPr>
+          <a:xfrm>
+            <a:off x="457200" y="1609344"/>
             <a:ext cx="6647688" cy="25603"/>
           </a:xfrm>
           <a:prstGeom prst="rect">
@@ -1038,14 +1077,14 @@
       </p:sp>
       <p:sp>
         <p:nvSpPr>
-          <p:cNvPr id="7" name="Text 4"/>
-          <p:cNvSpPr/>
-          <p:nvPr/>
-        </p:nvSpPr>
-        <p:spPr>
-          <a:xfrm>
-            <a:off x="457200" y="1773936"/>
-            <a:ext cx="6647688" cy="566928"/>
+          <p:cNvPr id="8" name="Text 5"/>
+          <p:cNvSpPr/>
+          <p:nvPr/>
+        </p:nvSpPr>
+        <p:spPr>
+          <a:xfrm>
+            <a:off x="457200" y="1737360"/>
+            <a:ext cx="6647688" cy="676656"/>
           </a:xfrm>
           <a:prstGeom prst="rect">
             <a:avLst/>
@@ -1072,7 +1111,7 @@
                 <a:ea typeface="Arial" pitchFamily="34" charset="-122"/>
                 <a:cs typeface="Arial" pitchFamily="34" charset="-120"/>
               </a:rPr>
-              <a:t>ELDA is a leadership development activity, not a classroom course. Participants lead and follow as a team through a demanding activity, where behaviour is exposed under genuine physical, mental and interpersonal load. Profiling, peer feedback and mental-skills training convert that experience into a written plan for the unit.</a:t>
+              <a:t>ELDA Command develops leaders who can perform, adapt and influence others under operational pressure. Rather than teaching leadership in a classroom, it exposes leadership behaviour through demanding physical, mental and interpersonal challenge, then converts that experience into lasting behavioural change. Every participant leaves with a written Leadership Development Plan grounded in observed behaviour rather than self-perception.</a:t>
             </a:r>
             <a:endParaRPr lang="en-US" sz="1000" dirty="0"/>
           </a:p>
@@ -1080,64 +1119,23 @@
       </p:sp>
       <p:sp>
         <p:nvSpPr>
-          <p:cNvPr id="8" name="Shape 5"/>
-          <p:cNvSpPr/>
-          <p:nvPr/>
-        </p:nvSpPr>
-        <p:spPr>
-          <a:xfrm>
-            <a:off x="457200" y="2432304"/>
-            <a:ext cx="6647688" cy="786384"/>
-          </a:xfrm>
-          <a:prstGeom prst="roundRect">
-            <a:avLst>
-              <a:gd name="adj" fmla="val 6977"/>
-            </a:avLst>
-          </a:prstGeom>
-          <a:solidFill>
-            <a:srgbClr val="002516"/>
-          </a:solidFill>
-          <a:ln/>
-        </p:spPr>
-      </p:sp>
-      <p:sp>
-        <p:nvSpPr>
-          <p:cNvPr id="9" name="Text 6"/>
-          <p:cNvSpPr/>
-          <p:nvPr/>
-        </p:nvSpPr>
-        <p:spPr>
-          <a:xfrm>
-            <a:off x="658368" y="2523744"/>
-            <a:ext cx="1097280" cy="182880"/>
-          </a:xfrm>
-          <a:prstGeom prst="rect">
-            <a:avLst/>
-          </a:prstGeom>
-          <a:noFill/>
-          <a:ln/>
-        </p:spPr>
-        <p:txBody>
-          <a:bodyPr wrap="square" lIns="0" tIns="0" rIns="0" bIns="0" rtlCol="0" anchor="ctr"/>
-          <a:lstStyle/>
-          <a:p>
-            <a:pPr algn="l" indent="0" marL="0">
-              <a:buNone/>
-            </a:pPr>
-            <a:r>
-              <a:rPr lang="en-US" sz="800" b="1" spc="160" kern="0" dirty="0">
-                <a:solidFill>
-                  <a:srgbClr val="CDD2B7"/>
-                </a:solidFill>
-                <a:latin typeface="Arial" pitchFamily="34" charset="0"/>
-                <a:ea typeface="Arial" pitchFamily="34" charset="-122"/>
-                <a:cs typeface="Arial" pitchFamily="34" charset="-120"/>
-              </a:rPr>
-              <a:t>AIM</a:t>
-            </a:r>
-            <a:endParaRPr lang="en-US" sz="800" dirty="0"/>
-          </a:p>
-        </p:txBody>
+          <p:cNvPr id="9" name="Shape 6"/>
+          <p:cNvSpPr/>
+          <p:nvPr/>
+        </p:nvSpPr>
+        <p:spPr>
+          <a:xfrm>
+            <a:off x="457200" y="2487168"/>
+            <a:ext cx="45720" cy="420624"/>
+          </a:xfrm>
+          <a:prstGeom prst="rect">
+            <a:avLst/>
+          </a:prstGeom>
+          <a:solidFill>
+            <a:srgbClr val="C62026"/>
+          </a:solidFill>
+          <a:ln/>
+        </p:spPr>
       </p:sp>
       <p:sp>
         <p:nvSpPr>
@@ -1147,8 +1145,8 @@
         </p:nvSpPr>
         <p:spPr>
           <a:xfrm>
-            <a:off x="658368" y="2706624"/>
-            <a:ext cx="6245352" cy="438912"/>
+            <a:off x="621792" y="2468880"/>
+            <a:ext cx="6483096" cy="475488"/>
           </a:xfrm>
           <a:prstGeom prst="rect">
             <a:avLst/>
@@ -1167,46 +1165,7 @@
               <a:buNone/>
             </a:pPr>
             <a:r>
-              <a:rPr lang="en-US" sz="950" dirty="0">
-                <a:solidFill>
-                  <a:srgbClr val="FFFFFF"/>
-                </a:solidFill>
-                <a:latin typeface="Arial" pitchFamily="34" charset="0"/>
-                <a:ea typeface="Arial" pitchFamily="34" charset="-122"/>
-                <a:cs typeface="Arial" pitchFamily="34" charset="-120"/>
-              </a:rPr>
-              <a:t>To enhance leadership and maintain warrior ethos in order to provide world class, operationally focused leaders. This is achieved through completing a challenging activity supported by leadership tools and selected psychometrics, followed by reflection and behaviour selection to increase effectiveness.</a:t>
-            </a:r>
-            <a:endParaRPr lang="en-US" sz="950" dirty="0"/>
-          </a:p>
-        </p:txBody>
-      </p:sp>
-      <p:sp>
-        <p:nvSpPr>
-          <p:cNvPr id="11" name="Text 8"/>
-          <p:cNvSpPr/>
-          <p:nvPr/>
-        </p:nvSpPr>
-        <p:spPr>
-          <a:xfrm>
-            <a:off x="457200" y="3328416"/>
-            <a:ext cx="6647688" cy="182880"/>
-          </a:xfrm>
-          <a:prstGeom prst="rect">
-            <a:avLst/>
-          </a:prstGeom>
-          <a:noFill/>
-          <a:ln/>
-        </p:spPr>
-        <p:txBody>
-          <a:bodyPr wrap="square" lIns="0" tIns="0" rIns="0" bIns="0" rtlCol="0" anchor="ctr"/>
-          <a:lstStyle/>
-          <a:p>
-            <a:pPr algn="l" indent="0" marL="0">
-              <a:buNone/>
-            </a:pPr>
-            <a:r>
-              <a:rPr lang="en-US" sz="850" b="1" spc="140" kern="0" dirty="0">
+              <a:rPr lang="en-US" sz="960" i="1" dirty="0">
                 <a:solidFill>
                   <a:srgbClr val="002516"/>
                 </a:solidFill>
@@ -1214,26 +1173,168 @@
                 <a:ea typeface="Arial" pitchFamily="34" charset="-122"/>
                 <a:cs typeface="Arial" pitchFamily="34" charset="-120"/>
               </a:rPr>
-              <a:t>LEARNING OUTCOMES</a:t>
-            </a:r>
-            <a:endParaRPr lang="en-US" sz="850" dirty="0"/>
-          </a:p>
-        </p:txBody>
-      </p:sp>
-      <p:sp>
-        <p:nvSpPr>
-          <p:cNvPr id="12" name="Shape 9"/>
-          <p:cNvSpPr/>
-          <p:nvPr/>
-        </p:nvSpPr>
-        <p:spPr>
-          <a:xfrm>
-            <a:off x="457200" y="3566160"/>
-            <a:ext cx="2130552" cy="749808"/>
+              <a:t>Leadership behaviour is most accurately revealed under sustained pressure, uncertainty and fatigue. ELDA deliberately creates those conditions, then uses structured reflection and peer feedback to convert experience into enduring behavioural change.</a:t>
+            </a:r>
+            <a:endParaRPr lang="en-US" sz="960" dirty="0"/>
+          </a:p>
+        </p:txBody>
+      </p:sp>
+      <p:sp>
+        <p:nvSpPr>
+          <p:cNvPr id="11" name="Shape 8"/>
+          <p:cNvSpPr/>
+          <p:nvPr/>
+        </p:nvSpPr>
+        <p:spPr>
+          <a:xfrm>
+            <a:off x="457200" y="2999232"/>
+            <a:ext cx="6647688" cy="603504"/>
           </a:xfrm>
           <a:prstGeom prst="roundRect">
             <a:avLst>
-              <a:gd name="adj" fmla="val 7317"/>
+              <a:gd name="adj" fmla="val 9091"/>
+            </a:avLst>
+          </a:prstGeom>
+          <a:solidFill>
+            <a:srgbClr val="002516"/>
+          </a:solidFill>
+          <a:ln/>
+        </p:spPr>
+      </p:sp>
+      <p:sp>
+        <p:nvSpPr>
+          <p:cNvPr id="12" name="Text 9"/>
+          <p:cNvSpPr/>
+          <p:nvPr/>
+        </p:nvSpPr>
+        <p:spPr>
+          <a:xfrm>
+            <a:off x="658368" y="3063240"/>
+            <a:ext cx="1097280" cy="164592"/>
+          </a:xfrm>
+          <a:prstGeom prst="rect">
+            <a:avLst/>
+          </a:prstGeom>
+          <a:noFill/>
+          <a:ln/>
+        </p:spPr>
+        <p:txBody>
+          <a:bodyPr wrap="square" lIns="0" tIns="0" rIns="0" bIns="0" rtlCol="0" anchor="ctr"/>
+          <a:lstStyle/>
+          <a:p>
+            <a:pPr algn="l" indent="0" marL="0">
+              <a:buNone/>
+            </a:pPr>
+            <a:r>
+              <a:rPr lang="en-US" sz="800" b="1" spc="160" kern="0" dirty="0">
+                <a:solidFill>
+                  <a:srgbClr val="CDD2B7"/>
+                </a:solidFill>
+                <a:latin typeface="Arial" pitchFamily="34" charset="0"/>
+                <a:ea typeface="Arial" pitchFamily="34" charset="-122"/>
+                <a:cs typeface="Arial" pitchFamily="34" charset="-120"/>
+              </a:rPr>
+              <a:t>AIM</a:t>
+            </a:r>
+            <a:endParaRPr lang="en-US" sz="800" dirty="0"/>
+          </a:p>
+        </p:txBody>
+      </p:sp>
+      <p:sp>
+        <p:nvSpPr>
+          <p:cNvPr id="13" name="Text 10"/>
+          <p:cNvSpPr/>
+          <p:nvPr/>
+        </p:nvSpPr>
+        <p:spPr>
+          <a:xfrm>
+            <a:off x="658368" y="3236976"/>
+            <a:ext cx="6245352" cy="310896"/>
+          </a:xfrm>
+          <a:prstGeom prst="rect">
+            <a:avLst/>
+          </a:prstGeom>
+          <a:noFill/>
+          <a:ln/>
+        </p:spPr>
+        <p:txBody>
+          <a:bodyPr wrap="square" lIns="0" tIns="0" rIns="0" bIns="0" rtlCol="0" anchor="t"/>
+          <a:lstStyle/>
+          <a:p>
+            <a:pPr algn="l" indent="0" marL="0">
+              <a:lnSpc>
+                <a:spcPct val="110000"/>
+              </a:lnSpc>
+              <a:buNone/>
+            </a:pPr>
+            <a:r>
+              <a:rPr lang="en-US" sz="960" dirty="0">
+                <a:solidFill>
+                  <a:srgbClr val="FFFFFF"/>
+                </a:solidFill>
+                <a:latin typeface="Arial" pitchFamily="34" charset="0"/>
+                <a:ea typeface="Arial" pitchFamily="34" charset="-122"/>
+                <a:cs typeface="Arial" pitchFamily="34" charset="-120"/>
+              </a:rPr>
+              <a:t>To develop leaders who can consistently perform, adapt and influence others under pressure, while strengthening individual effectiveness and collective team performance.</a:t>
+            </a:r>
+            <a:endParaRPr lang="en-US" sz="960" dirty="0"/>
+          </a:p>
+        </p:txBody>
+      </p:sp>
+      <p:sp>
+        <p:nvSpPr>
+          <p:cNvPr id="14" name="Text 11"/>
+          <p:cNvSpPr/>
+          <p:nvPr/>
+        </p:nvSpPr>
+        <p:spPr>
+          <a:xfrm>
+            <a:off x="457200" y="3675888"/>
+            <a:ext cx="6647688" cy="182880"/>
+          </a:xfrm>
+          <a:prstGeom prst="rect">
+            <a:avLst/>
+          </a:prstGeom>
+          <a:noFill/>
+          <a:ln/>
+        </p:spPr>
+        <p:txBody>
+          <a:bodyPr wrap="square" lIns="0" tIns="0" rIns="0" bIns="0" rtlCol="0" anchor="ctr"/>
+          <a:lstStyle/>
+          <a:p>
+            <a:pPr algn="l" indent="0" marL="0">
+              <a:buNone/>
+            </a:pPr>
+            <a:r>
+              <a:rPr lang="en-US" sz="850" b="1" spc="140" kern="0" dirty="0">
+                <a:solidFill>
+                  <a:srgbClr val="002516"/>
+                </a:solidFill>
+                <a:latin typeface="Arial" pitchFamily="34" charset="0"/>
+                <a:ea typeface="Arial" pitchFamily="34" charset="-122"/>
+                <a:cs typeface="Arial" pitchFamily="34" charset="-120"/>
+              </a:rPr>
+              <a:t>LEARNING OUTCOMES</a:t>
+            </a:r>
+            <a:endParaRPr lang="en-US" sz="850" dirty="0"/>
+          </a:p>
+        </p:txBody>
+      </p:sp>
+      <p:sp>
+        <p:nvSpPr>
+          <p:cNvPr id="15" name="Shape 12"/>
+          <p:cNvSpPr/>
+          <p:nvPr/>
+        </p:nvSpPr>
+        <p:spPr>
+          <a:xfrm>
+            <a:off x="457200" y="3877056"/>
+            <a:ext cx="2130552" cy="694944"/>
+          </a:xfrm>
+          <a:prstGeom prst="roundRect">
+            <a:avLst>
+              <a:gd name="adj" fmla="val 7895"/>
             </a:avLst>
           </a:prstGeom>
           <a:solidFill>
@@ -1251,13 +1352,13 @@
       </p:sp>
       <p:sp>
         <p:nvSpPr>
-          <p:cNvPr id="13" name="Shape 10"/>
-          <p:cNvSpPr/>
-          <p:nvPr/>
-        </p:nvSpPr>
-        <p:spPr>
-          <a:xfrm>
-            <a:off x="585216" y="3675888"/>
+          <p:cNvPr id="16" name="Shape 13"/>
+          <p:cNvSpPr/>
+          <p:nvPr/>
+        </p:nvSpPr>
+        <p:spPr>
+          <a:xfrm>
+            <a:off x="585216" y="3968496"/>
             <a:ext cx="201168" cy="201168"/>
           </a:xfrm>
           <a:prstGeom prst="ellipse">
@@ -1271,13 +1372,13 @@
       </p:sp>
       <p:sp>
         <p:nvSpPr>
-          <p:cNvPr id="14" name="Text 11"/>
-          <p:cNvSpPr/>
-          <p:nvPr/>
-        </p:nvSpPr>
-        <p:spPr>
-          <a:xfrm>
-            <a:off x="585216" y="3675888"/>
+          <p:cNvPr id="17" name="Text 14"/>
+          <p:cNvSpPr/>
+          <p:nvPr/>
+        </p:nvSpPr>
+        <p:spPr>
+          <a:xfrm>
+            <a:off x="585216" y="3968496"/>
             <a:ext cx="201168" cy="201168"/>
           </a:xfrm>
           <a:prstGeom prst="rect">
@@ -1310,13 +1411,13 @@
       </p:sp>
       <p:sp>
         <p:nvSpPr>
-          <p:cNvPr id="15" name="Text 12"/>
-          <p:cNvSpPr/>
-          <p:nvPr/>
-        </p:nvSpPr>
-        <p:spPr>
-          <a:xfrm>
-            <a:off x="841248" y="3675888"/>
+          <p:cNvPr id="18" name="Text 15"/>
+          <p:cNvSpPr/>
+          <p:nvPr/>
+        </p:nvSpPr>
+        <p:spPr>
+          <a:xfrm>
+            <a:off x="841248" y="3968496"/>
             <a:ext cx="1618488" cy="201168"/>
           </a:xfrm>
           <a:prstGeom prst="rect">
@@ -1349,14 +1450,14 @@
       </p:sp>
       <p:sp>
         <p:nvSpPr>
-          <p:cNvPr id="16" name="Text 13"/>
-          <p:cNvSpPr/>
-          <p:nvPr/>
-        </p:nvSpPr>
-        <p:spPr>
-          <a:xfrm>
-            <a:off x="585216" y="3895344"/>
-            <a:ext cx="1874520" cy="384048"/>
+          <p:cNvPr id="19" name="Text 16"/>
+          <p:cNvSpPr/>
+          <p:nvPr/>
+        </p:nvSpPr>
+        <p:spPr>
+          <a:xfrm>
+            <a:off x="585216" y="4187952"/>
+            <a:ext cx="1874520" cy="365760"/>
           </a:xfrm>
           <a:prstGeom prst="rect">
             <a:avLst/>
@@ -1383,7 +1484,7 @@
                 <a:ea typeface="Arial" pitchFamily="34" charset="-122"/>
                 <a:cs typeface="Arial" pitchFamily="34" charset="-120"/>
               </a:rPr>
-              <a:t>Develop the mental skills to perform under pressure.</a:t>
+              <a:t>Build the mental skills to perform and decide under pressure.</a:t>
             </a:r>
             <a:endParaRPr lang="en-US" sz="840" dirty="0"/>
           </a:p>
@@ -1391,18 +1492,18 @@
       </p:sp>
       <p:sp>
         <p:nvSpPr>
-          <p:cNvPr id="17" name="Shape 14"/>
-          <p:cNvSpPr/>
-          <p:nvPr/>
-        </p:nvSpPr>
-        <p:spPr>
-          <a:xfrm>
-            <a:off x="2715768" y="3566160"/>
-            <a:ext cx="2130552" cy="749808"/>
+          <p:cNvPr id="20" name="Shape 17"/>
+          <p:cNvSpPr/>
+          <p:nvPr/>
+        </p:nvSpPr>
+        <p:spPr>
+          <a:xfrm>
+            <a:off x="2715768" y="3877056"/>
+            <a:ext cx="2130552" cy="694944"/>
           </a:xfrm>
           <a:prstGeom prst="roundRect">
             <a:avLst>
-              <a:gd name="adj" fmla="val 7317"/>
+              <a:gd name="adj" fmla="val 7895"/>
             </a:avLst>
           </a:prstGeom>
           <a:solidFill>
@@ -1420,13 +1521,13 @@
       </p:sp>
       <p:sp>
         <p:nvSpPr>
-          <p:cNvPr id="18" name="Shape 15"/>
-          <p:cNvSpPr/>
-          <p:nvPr/>
-        </p:nvSpPr>
-        <p:spPr>
-          <a:xfrm>
-            <a:off x="2843784" y="3675888"/>
+          <p:cNvPr id="21" name="Shape 18"/>
+          <p:cNvSpPr/>
+          <p:nvPr/>
+        </p:nvSpPr>
+        <p:spPr>
+          <a:xfrm>
+            <a:off x="2843784" y="3968496"/>
             <a:ext cx="201168" cy="201168"/>
           </a:xfrm>
           <a:prstGeom prst="ellipse">
@@ -1440,13 +1541,13 @@
       </p:sp>
       <p:sp>
         <p:nvSpPr>
-          <p:cNvPr id="19" name="Text 16"/>
-          <p:cNvSpPr/>
-          <p:nvPr/>
-        </p:nvSpPr>
-        <p:spPr>
-          <a:xfrm>
-            <a:off x="2843784" y="3675888"/>
+          <p:cNvPr id="22" name="Text 19"/>
+          <p:cNvSpPr/>
+          <p:nvPr/>
+        </p:nvSpPr>
+        <p:spPr>
+          <a:xfrm>
+            <a:off x="2843784" y="3968496"/>
             <a:ext cx="201168" cy="201168"/>
           </a:xfrm>
           <a:prstGeom prst="rect">
@@ -1479,13 +1580,13 @@
       </p:sp>
       <p:sp>
         <p:nvSpPr>
-          <p:cNvPr id="20" name="Text 17"/>
-          <p:cNvSpPr/>
-          <p:nvPr/>
-        </p:nvSpPr>
-        <p:spPr>
-          <a:xfrm>
-            <a:off x="3099816" y="3675888"/>
+          <p:cNvPr id="23" name="Text 20"/>
+          <p:cNvSpPr/>
+          <p:nvPr/>
+        </p:nvSpPr>
+        <p:spPr>
+          <a:xfrm>
+            <a:off x="3099816" y="3968496"/>
             <a:ext cx="1618488" cy="201168"/>
           </a:xfrm>
           <a:prstGeom prst="rect">
@@ -1518,14 +1619,14 @@
       </p:sp>
       <p:sp>
         <p:nvSpPr>
-          <p:cNvPr id="21" name="Text 18"/>
-          <p:cNvSpPr/>
-          <p:nvPr/>
-        </p:nvSpPr>
-        <p:spPr>
-          <a:xfrm>
-            <a:off x="2843784" y="3895344"/>
-            <a:ext cx="1874520" cy="384048"/>
+          <p:cNvPr id="24" name="Text 21"/>
+          <p:cNvSpPr/>
+          <p:nvPr/>
+        </p:nvSpPr>
+        <p:spPr>
+          <a:xfrm>
+            <a:off x="2843784" y="4187952"/>
+            <a:ext cx="1874520" cy="365760"/>
           </a:xfrm>
           <a:prstGeom prst="rect">
             <a:avLst/>
@@ -1552,7 +1653,7 @@
                 <a:ea typeface="Arial" pitchFamily="34" charset="-122"/>
                 <a:cs typeface="Arial" pitchFamily="34" charset="-120"/>
               </a:rPr>
-              <a:t>Lead and follow through a genuinely challenging serial.</a:t>
+              <a:t>Lead and follow through a genuinely demanding serial.</a:t>
             </a:r>
             <a:endParaRPr lang="en-US" sz="840" dirty="0"/>
           </a:p>
@@ -1560,18 +1661,18 @@
       </p:sp>
       <p:sp>
         <p:nvSpPr>
-          <p:cNvPr id="22" name="Shape 19"/>
-          <p:cNvSpPr/>
-          <p:nvPr/>
-        </p:nvSpPr>
-        <p:spPr>
-          <a:xfrm>
-            <a:off x="4974336" y="3566160"/>
-            <a:ext cx="2130552" cy="749808"/>
+          <p:cNvPr id="25" name="Shape 22"/>
+          <p:cNvSpPr/>
+          <p:nvPr/>
+        </p:nvSpPr>
+        <p:spPr>
+          <a:xfrm>
+            <a:off x="4974336" y="3877056"/>
+            <a:ext cx="2130552" cy="694944"/>
           </a:xfrm>
           <a:prstGeom prst="roundRect">
             <a:avLst>
-              <a:gd name="adj" fmla="val 7317"/>
+              <a:gd name="adj" fmla="val 7895"/>
             </a:avLst>
           </a:prstGeom>
           <a:solidFill>
@@ -1589,13 +1690,13 @@
       </p:sp>
       <p:sp>
         <p:nvSpPr>
-          <p:cNvPr id="23" name="Shape 20"/>
-          <p:cNvSpPr/>
-          <p:nvPr/>
-        </p:nvSpPr>
-        <p:spPr>
-          <a:xfrm>
-            <a:off x="5102352" y="3675888"/>
+          <p:cNvPr id="26" name="Shape 23"/>
+          <p:cNvSpPr/>
+          <p:nvPr/>
+        </p:nvSpPr>
+        <p:spPr>
+          <a:xfrm>
+            <a:off x="5102352" y="3968496"/>
             <a:ext cx="201168" cy="201168"/>
           </a:xfrm>
           <a:prstGeom prst="ellipse">
@@ -1609,13 +1710,13 @@
       </p:sp>
       <p:sp>
         <p:nvSpPr>
-          <p:cNvPr id="24" name="Text 21"/>
-          <p:cNvSpPr/>
-          <p:nvPr/>
-        </p:nvSpPr>
-        <p:spPr>
-          <a:xfrm>
-            <a:off x="5102352" y="3675888"/>
+          <p:cNvPr id="27" name="Text 24"/>
+          <p:cNvSpPr/>
+          <p:nvPr/>
+        </p:nvSpPr>
+        <p:spPr>
+          <a:xfrm>
+            <a:off x="5102352" y="3968496"/>
             <a:ext cx="201168" cy="201168"/>
           </a:xfrm>
           <a:prstGeom prst="rect">
@@ -1648,13 +1749,13 @@
       </p:sp>
       <p:sp>
         <p:nvSpPr>
-          <p:cNvPr id="25" name="Text 22"/>
-          <p:cNvSpPr/>
-          <p:nvPr/>
-        </p:nvSpPr>
-        <p:spPr>
-          <a:xfrm>
-            <a:off x="5358384" y="3675888"/>
+          <p:cNvPr id="28" name="Text 25"/>
+          <p:cNvSpPr/>
+          <p:nvPr/>
+        </p:nvSpPr>
+        <p:spPr>
+          <a:xfrm>
+            <a:off x="5358384" y="3968496"/>
             <a:ext cx="1618488" cy="201168"/>
           </a:xfrm>
           <a:prstGeom prst="rect">
@@ -1687,14 +1788,14 @@
       </p:sp>
       <p:sp>
         <p:nvSpPr>
-          <p:cNvPr id="26" name="Text 23"/>
-          <p:cNvSpPr/>
-          <p:nvPr/>
-        </p:nvSpPr>
-        <p:spPr>
-          <a:xfrm>
-            <a:off x="5102352" y="3895344"/>
-            <a:ext cx="1874520" cy="384048"/>
+          <p:cNvPr id="29" name="Text 26"/>
+          <p:cNvSpPr/>
+          <p:nvPr/>
+        </p:nvSpPr>
+        <p:spPr>
+          <a:xfrm>
+            <a:off x="5102352" y="4187952"/>
+            <a:ext cx="1874520" cy="365760"/>
           </a:xfrm>
           <a:prstGeom prst="rect">
             <a:avLst/>
@@ -1721,7 +1822,7 @@
                 <a:ea typeface="Arial" pitchFamily="34" charset="-122"/>
                 <a:cs typeface="Arial" pitchFamily="34" charset="-120"/>
               </a:rPr>
-              <a:t>Leave with an actionable plan for the workplace.</a:t>
+              <a:t>Transfer observed behaviour into command effectiveness.</a:t>
             </a:r>
             <a:endParaRPr lang="en-US" sz="840" dirty="0"/>
           </a:p>
@@ -1729,13 +1830,13 @@
       </p:sp>
       <p:sp>
         <p:nvSpPr>
-          <p:cNvPr id="27" name="Text 24"/>
-          <p:cNvSpPr/>
-          <p:nvPr/>
-        </p:nvSpPr>
-        <p:spPr>
-          <a:xfrm>
-            <a:off x="457200" y="4443984"/>
+          <p:cNvPr id="30" name="Text 27"/>
+          <p:cNvSpPr/>
+          <p:nvPr/>
+        </p:nvSpPr>
+        <p:spPr>
+          <a:xfrm>
+            <a:off x="457200" y="4663440"/>
             <a:ext cx="6647688" cy="182880"/>
           </a:xfrm>
           <a:prstGeom prst="rect">
@@ -1768,13 +1869,13 @@
       </p:sp>
       <p:sp>
         <p:nvSpPr>
-          <p:cNvPr id="28" name="Shape 25"/>
-          <p:cNvSpPr/>
-          <p:nvPr/>
-        </p:nvSpPr>
-        <p:spPr>
-          <a:xfrm>
-            <a:off x="457200" y="4681728"/>
+          <p:cNvPr id="31" name="Shape 28"/>
+          <p:cNvSpPr/>
+          <p:nvPr/>
+        </p:nvSpPr>
+        <p:spPr>
+          <a:xfrm>
+            <a:off x="457200" y="4864608"/>
             <a:ext cx="2130552" cy="237744"/>
           </a:xfrm>
           <a:prstGeom prst="rect">
@@ -1788,13 +1889,13 @@
       </p:sp>
       <p:sp>
         <p:nvSpPr>
-          <p:cNvPr id="29" name="Text 26"/>
-          <p:cNvSpPr/>
-          <p:nvPr/>
-        </p:nvSpPr>
-        <p:spPr>
-          <a:xfrm>
-            <a:off x="457200" y="4681728"/>
+          <p:cNvPr id="32" name="Text 29"/>
+          <p:cNvSpPr/>
+          <p:nvPr/>
+        </p:nvSpPr>
+        <p:spPr>
+          <a:xfrm>
+            <a:off x="457200" y="4864608"/>
             <a:ext cx="2130552" cy="237744"/>
           </a:xfrm>
           <a:prstGeom prst="rect">
@@ -1827,14 +1928,14 @@
       </p:sp>
       <p:sp>
         <p:nvSpPr>
-          <p:cNvPr id="30" name="Text 27"/>
-          <p:cNvSpPr/>
-          <p:nvPr/>
-        </p:nvSpPr>
-        <p:spPr>
-          <a:xfrm>
-            <a:off x="475488" y="4974336"/>
-            <a:ext cx="2093976" cy="1207008"/>
+          <p:cNvPr id="33" name="Text 30"/>
+          <p:cNvSpPr/>
+          <p:nvPr/>
+        </p:nvSpPr>
+        <p:spPr>
+          <a:xfrm>
+            <a:off x="475488" y="5148072"/>
+            <a:ext cx="2093976" cy="1115568"/>
           </a:xfrm>
           <a:prstGeom prst="rect">
             <a:avLst/>
@@ -1851,7 +1952,7 @@
                 <a:spcPct val="110000"/>
               </a:lnSpc>
               <a:spcAft>
-                <a:spcPts val="500"/>
+                <a:spcPts val="400"/>
               </a:spcAft>
               <a:buSzPct val="100000"/>
               <a:buChar char="•"/>
@@ -1865,7 +1966,7 @@
                 <a:ea typeface="Arial" pitchFamily="34" charset="-122"/>
                 <a:cs typeface="Arial" pitchFamily="34" charset="-120"/>
               </a:rPr>
-              <a:t>Leadership Personality Report: a Five Factor profile covering day to day behaviour, behaviour under pressure, and personal drivers.</a:t>
+              <a:t>Leadership Personality Report: a Five Factor profile of behaviour day to day, under pressure, and the drivers behind it.</a:t>
             </a:r>
             <a:endParaRPr lang="en-US" sz="820" dirty="0"/>
           </a:p>
@@ -1875,7 +1976,7 @@
                 <a:spcPct val="110000"/>
               </a:lnSpc>
               <a:spcAft>
-                <a:spcPts val="500"/>
+                <a:spcPts val="400"/>
               </a:spcAft>
               <a:buSzPct val="100000"/>
               <a:buChar char="•"/>
@@ -1899,7 +2000,7 @@
                 <a:spcPct val="110000"/>
               </a:lnSpc>
               <a:spcAft>
-                <a:spcPts val="500"/>
+                <a:spcPts val="400"/>
               </a:spcAft>
               <a:buSzPct val="100000"/>
               <a:buChar char="•"/>
@@ -1921,13 +2022,13 @@
       </p:sp>
       <p:sp>
         <p:nvSpPr>
-          <p:cNvPr id="31" name="Shape 28"/>
-          <p:cNvSpPr/>
-          <p:nvPr/>
-        </p:nvSpPr>
-        <p:spPr>
-          <a:xfrm>
-            <a:off x="2715768" y="4681728"/>
+          <p:cNvPr id="34" name="Shape 31"/>
+          <p:cNvSpPr/>
+          <p:nvPr/>
+        </p:nvSpPr>
+        <p:spPr>
+          <a:xfrm>
+            <a:off x="2715768" y="4864608"/>
             <a:ext cx="2130552" cy="237744"/>
           </a:xfrm>
           <a:prstGeom prst="rect">
@@ -1941,13 +2042,13 @@
       </p:sp>
       <p:sp>
         <p:nvSpPr>
-          <p:cNvPr id="32" name="Text 29"/>
-          <p:cNvSpPr/>
-          <p:nvPr/>
-        </p:nvSpPr>
-        <p:spPr>
-          <a:xfrm>
-            <a:off x="2715768" y="4681728"/>
+          <p:cNvPr id="35" name="Text 32"/>
+          <p:cNvSpPr/>
+          <p:nvPr/>
+        </p:nvSpPr>
+        <p:spPr>
+          <a:xfrm>
+            <a:off x="2715768" y="4864608"/>
             <a:ext cx="2130552" cy="237744"/>
           </a:xfrm>
           <a:prstGeom prst="rect">
@@ -1980,14 +2081,14 @@
       </p:sp>
       <p:sp>
         <p:nvSpPr>
-          <p:cNvPr id="33" name="Text 30"/>
-          <p:cNvSpPr/>
-          <p:nvPr/>
-        </p:nvSpPr>
-        <p:spPr>
-          <a:xfrm>
-            <a:off x="2734056" y="4974336"/>
-            <a:ext cx="2093976" cy="1207008"/>
+          <p:cNvPr id="36" name="Text 33"/>
+          <p:cNvSpPr/>
+          <p:nvPr/>
+        </p:nvSpPr>
+        <p:spPr>
+          <a:xfrm>
+            <a:off x="2734056" y="5148072"/>
+            <a:ext cx="2093976" cy="1115568"/>
           </a:xfrm>
           <a:prstGeom prst="rect">
             <a:avLst/>
@@ -2004,7 +2105,7 @@
                 <a:spcPct val="110000"/>
               </a:lnSpc>
               <a:spcAft>
-                <a:spcPts val="500"/>
+                <a:spcPts val="400"/>
               </a:spcAft>
               <a:buSzPct val="100000"/>
               <a:buChar char="•"/>
@@ -2028,7 +2129,7 @@
                 <a:spcPct val="110000"/>
               </a:lnSpc>
               <a:spcAft>
-                <a:spcPts val="500"/>
+                <a:spcPts val="400"/>
               </a:spcAft>
               <a:buSzPct val="100000"/>
               <a:buChar char="•"/>
@@ -2052,7 +2153,7 @@
                 <a:spcPct val="110000"/>
               </a:lnSpc>
               <a:spcAft>
-                <a:spcPts val="500"/>
+                <a:spcPts val="400"/>
               </a:spcAft>
               <a:buSzPct val="100000"/>
               <a:buChar char="•"/>
@@ -2074,13 +2175,13 @@
       </p:sp>
       <p:sp>
         <p:nvSpPr>
-          <p:cNvPr id="34" name="Shape 31"/>
-          <p:cNvSpPr/>
-          <p:nvPr/>
-        </p:nvSpPr>
-        <p:spPr>
-          <a:xfrm>
-            <a:off x="4974336" y="4681728"/>
+          <p:cNvPr id="37" name="Shape 34"/>
+          <p:cNvSpPr/>
+          <p:nvPr/>
+        </p:nvSpPr>
+        <p:spPr>
+          <a:xfrm>
+            <a:off x="4974336" y="4864608"/>
             <a:ext cx="2130552" cy="237744"/>
           </a:xfrm>
           <a:prstGeom prst="rect">
@@ -2094,13 +2195,13 @@
       </p:sp>
       <p:sp>
         <p:nvSpPr>
-          <p:cNvPr id="35" name="Text 32"/>
-          <p:cNvSpPr/>
-          <p:nvPr/>
-        </p:nvSpPr>
-        <p:spPr>
-          <a:xfrm>
-            <a:off x="4974336" y="4681728"/>
+          <p:cNvPr id="38" name="Text 35"/>
+          <p:cNvSpPr/>
+          <p:nvPr/>
+        </p:nvSpPr>
+        <p:spPr>
+          <a:xfrm>
+            <a:off x="4974336" y="4864608"/>
             <a:ext cx="2130552" cy="237744"/>
           </a:xfrm>
           <a:prstGeom prst="rect">
@@ -2133,14 +2234,14 @@
       </p:sp>
       <p:sp>
         <p:nvSpPr>
-          <p:cNvPr id="36" name="Text 33"/>
-          <p:cNvSpPr/>
-          <p:nvPr/>
-        </p:nvSpPr>
-        <p:spPr>
-          <a:xfrm>
-            <a:off x="4992624" y="4974336"/>
-            <a:ext cx="2093976" cy="1207008"/>
+          <p:cNvPr id="39" name="Text 36"/>
+          <p:cNvSpPr/>
+          <p:nvPr/>
+        </p:nvSpPr>
+        <p:spPr>
+          <a:xfrm>
+            <a:off x="4992624" y="5148072"/>
+            <a:ext cx="2093976" cy="1115568"/>
           </a:xfrm>
           <a:prstGeom prst="rect">
             <a:avLst/>
@@ -2157,7 +2258,7 @@
                 <a:spcPct val="110000"/>
               </a:lnSpc>
               <a:spcAft>
-                <a:spcPts val="500"/>
+                <a:spcPts val="400"/>
               </a:spcAft>
               <a:buSzPct val="100000"/>
               <a:buChar char="•"/>
@@ -2181,7 +2282,7 @@
                 <a:spcPct val="110000"/>
               </a:lnSpc>
               <a:spcAft>
-                <a:spcPts val="500"/>
+                <a:spcPts val="400"/>
               </a:spcAft>
               <a:buSzPct val="100000"/>
               <a:buChar char="•"/>
@@ -2205,7 +2306,7 @@
                 <a:spcPct val="110000"/>
               </a:lnSpc>
               <a:spcAft>
-                <a:spcPts val="500"/>
+                <a:spcPts val="400"/>
               </a:spcAft>
               <a:buSzPct val="100000"/>
               <a:buChar char="•"/>
@@ -2227,13 +2328,13 @@
       </p:sp>
       <p:sp>
         <p:nvSpPr>
-          <p:cNvPr id="37" name="Text 34"/>
-          <p:cNvSpPr/>
-          <p:nvPr/>
-        </p:nvSpPr>
-        <p:spPr>
-          <a:xfrm>
-            <a:off x="457200" y="6272784"/>
+          <p:cNvPr id="40" name="Text 37"/>
+          <p:cNvSpPr/>
+          <p:nvPr/>
+        </p:nvSpPr>
+        <p:spPr>
+          <a:xfrm>
+            <a:off x="457200" y="6400800"/>
             <a:ext cx="6647688" cy="182880"/>
           </a:xfrm>
           <a:prstGeom prst="rect">
@@ -2266,14 +2367,14 @@
       </p:sp>
       <p:sp>
         <p:nvSpPr>
-          <p:cNvPr id="38" name="Shape 35"/>
-          <p:cNvSpPr/>
-          <p:nvPr/>
-        </p:nvSpPr>
-        <p:spPr>
-          <a:xfrm>
-            <a:off x="457200" y="6551676"/>
-            <a:ext cx="41148" cy="132588"/>
+          <p:cNvPr id="41" name="Shape 38"/>
+          <p:cNvSpPr/>
+          <p:nvPr/>
+        </p:nvSpPr>
+        <p:spPr>
+          <a:xfrm>
+            <a:off x="457200" y="6638544"/>
+            <a:ext cx="41148" cy="128016"/>
           </a:xfrm>
           <a:prstGeom prst="rect">
             <a:avLst/>
@@ -2286,13 +2387,13 @@
       </p:sp>
       <p:sp>
         <p:nvSpPr>
-          <p:cNvPr id="39" name="Text 36"/>
-          <p:cNvSpPr/>
-          <p:nvPr/>
-        </p:nvSpPr>
-        <p:spPr>
-          <a:xfrm>
-            <a:off x="585216" y="6510528"/>
+          <p:cNvPr id="42" name="Text 39"/>
+          <p:cNvSpPr/>
+          <p:nvPr/>
+        </p:nvSpPr>
+        <p:spPr>
+          <a:xfrm>
+            <a:off x="585216" y="6601968"/>
             <a:ext cx="1874520" cy="201168"/>
           </a:xfrm>
           <a:prstGeom prst="rect">
@@ -2325,14 +2426,14 @@
       </p:sp>
       <p:sp>
         <p:nvSpPr>
-          <p:cNvPr id="40" name="Text 37"/>
-          <p:cNvSpPr/>
-          <p:nvPr/>
-        </p:nvSpPr>
-        <p:spPr>
-          <a:xfrm>
-            <a:off x="2505456" y="6510528"/>
-            <a:ext cx="4599432" cy="420624"/>
+          <p:cNvPr id="43" name="Text 40"/>
+          <p:cNvSpPr/>
+          <p:nvPr/>
+        </p:nvSpPr>
+        <p:spPr>
+          <a:xfrm>
+            <a:off x="2505456" y="6601968"/>
+            <a:ext cx="4599432" cy="402336"/>
           </a:xfrm>
           <a:prstGeom prst="rect">
             <a:avLst/>
@@ -2367,14 +2468,14 @@
       </p:sp>
       <p:sp>
         <p:nvSpPr>
-          <p:cNvPr id="41" name="Shape 38"/>
-          <p:cNvSpPr/>
-          <p:nvPr/>
-        </p:nvSpPr>
-        <p:spPr>
-          <a:xfrm>
-            <a:off x="457200" y="7027164"/>
-            <a:ext cx="41148" cy="132588"/>
+          <p:cNvPr id="44" name="Shape 41"/>
+          <p:cNvSpPr/>
+          <p:nvPr/>
+        </p:nvSpPr>
+        <p:spPr>
+          <a:xfrm>
+            <a:off x="457200" y="7059168"/>
+            <a:ext cx="41148" cy="128016"/>
           </a:xfrm>
           <a:prstGeom prst="rect">
             <a:avLst/>
@@ -2387,13 +2488,13 @@
       </p:sp>
       <p:sp>
         <p:nvSpPr>
-          <p:cNvPr id="42" name="Text 39"/>
-          <p:cNvSpPr/>
-          <p:nvPr/>
-        </p:nvSpPr>
-        <p:spPr>
-          <a:xfrm>
-            <a:off x="585216" y="6986016"/>
+          <p:cNvPr id="45" name="Text 42"/>
+          <p:cNvSpPr/>
+          <p:nvPr/>
+        </p:nvSpPr>
+        <p:spPr>
+          <a:xfrm>
+            <a:off x="585216" y="7022592"/>
             <a:ext cx="1874520" cy="201168"/>
           </a:xfrm>
           <a:prstGeom prst="rect">
@@ -2426,14 +2527,14 @@
       </p:sp>
       <p:sp>
         <p:nvSpPr>
-          <p:cNvPr id="43" name="Text 40"/>
-          <p:cNvSpPr/>
-          <p:nvPr/>
-        </p:nvSpPr>
-        <p:spPr>
-          <a:xfrm>
-            <a:off x="2505456" y="6986016"/>
-            <a:ext cx="4599432" cy="420624"/>
+          <p:cNvPr id="46" name="Text 43"/>
+          <p:cNvSpPr/>
+          <p:nvPr/>
+        </p:nvSpPr>
+        <p:spPr>
+          <a:xfrm>
+            <a:off x="2505456" y="7022592"/>
+            <a:ext cx="4599432" cy="402336"/>
           </a:xfrm>
           <a:prstGeom prst="rect">
             <a:avLst/>
@@ -2468,14 +2569,14 @@
       </p:sp>
       <p:sp>
         <p:nvSpPr>
-          <p:cNvPr id="44" name="Shape 41"/>
-          <p:cNvSpPr/>
-          <p:nvPr/>
-        </p:nvSpPr>
-        <p:spPr>
-          <a:xfrm>
-            <a:off x="457200" y="7502652"/>
-            <a:ext cx="41148" cy="132588"/>
+          <p:cNvPr id="47" name="Shape 44"/>
+          <p:cNvSpPr/>
+          <p:nvPr/>
+        </p:nvSpPr>
+        <p:spPr>
+          <a:xfrm>
+            <a:off x="457200" y="7479792"/>
+            <a:ext cx="41148" cy="128016"/>
           </a:xfrm>
           <a:prstGeom prst="rect">
             <a:avLst/>
@@ -2488,13 +2589,13 @@
       </p:sp>
       <p:sp>
         <p:nvSpPr>
-          <p:cNvPr id="45" name="Text 42"/>
-          <p:cNvSpPr/>
-          <p:nvPr/>
-        </p:nvSpPr>
-        <p:spPr>
-          <a:xfrm>
-            <a:off x="585216" y="7461504"/>
+          <p:cNvPr id="48" name="Text 45"/>
+          <p:cNvSpPr/>
+          <p:nvPr/>
+        </p:nvSpPr>
+        <p:spPr>
+          <a:xfrm>
+            <a:off x="585216" y="7443216"/>
             <a:ext cx="1874520" cy="201168"/>
           </a:xfrm>
           <a:prstGeom prst="rect">
@@ -2527,14 +2628,14 @@
       </p:sp>
       <p:sp>
         <p:nvSpPr>
-          <p:cNvPr id="46" name="Text 43"/>
-          <p:cNvSpPr/>
-          <p:nvPr/>
-        </p:nvSpPr>
-        <p:spPr>
-          <a:xfrm>
-            <a:off x="2505456" y="7461504"/>
-            <a:ext cx="4599432" cy="420624"/>
+          <p:cNvPr id="49" name="Text 46"/>
+          <p:cNvSpPr/>
+          <p:nvPr/>
+        </p:nvSpPr>
+        <p:spPr>
+          <a:xfrm>
+            <a:off x="2505456" y="7443216"/>
+            <a:ext cx="4599432" cy="402336"/>
           </a:xfrm>
           <a:prstGeom prst="rect">
             <a:avLst/>
@@ -2561,7 +2662,7 @@
                 <a:ea typeface="Arial" pitchFamily="34" charset="-122"/>
                 <a:cs typeface="Arial" pitchFamily="34" charset="-120"/>
               </a:rPr>
-              <a:t>Every participant gives and receives specific behavioural feedback on one development area and one strength, evidenced by what was observed during the activity.</a:t>
+              <a:t>Every participant gives and receives specific behavioural feedback on one strength to sustain and one behaviour to adapt, evidenced by what was observed during the activity.</a:t>
             </a:r>
             <a:endParaRPr lang="en-US" sz="820" dirty="0"/>
           </a:p>
@@ -2569,14 +2670,14 @@
       </p:sp>
       <p:sp>
         <p:nvSpPr>
-          <p:cNvPr id="47" name="Shape 44"/>
-          <p:cNvSpPr/>
-          <p:nvPr/>
-        </p:nvSpPr>
-        <p:spPr>
-          <a:xfrm>
-            <a:off x="457200" y="7978140"/>
-            <a:ext cx="41148" cy="132588"/>
+          <p:cNvPr id="50" name="Shape 47"/>
+          <p:cNvSpPr/>
+          <p:nvPr/>
+        </p:nvSpPr>
+        <p:spPr>
+          <a:xfrm>
+            <a:off x="457200" y="7900416"/>
+            <a:ext cx="41148" cy="128016"/>
           </a:xfrm>
           <a:prstGeom prst="rect">
             <a:avLst/>
@@ -2589,13 +2690,13 @@
       </p:sp>
       <p:sp>
         <p:nvSpPr>
-          <p:cNvPr id="48" name="Text 45"/>
-          <p:cNvSpPr/>
-          <p:nvPr/>
-        </p:nvSpPr>
-        <p:spPr>
-          <a:xfrm>
-            <a:off x="585216" y="7936992"/>
+          <p:cNvPr id="51" name="Text 48"/>
+          <p:cNvSpPr/>
+          <p:nvPr/>
+        </p:nvSpPr>
+        <p:spPr>
+          <a:xfrm>
+            <a:off x="585216" y="7863840"/>
             <a:ext cx="1874520" cy="201168"/>
           </a:xfrm>
           <a:prstGeom prst="rect">
@@ -2628,14 +2729,14 @@
       </p:sp>
       <p:sp>
         <p:nvSpPr>
-          <p:cNvPr id="49" name="Text 46"/>
-          <p:cNvSpPr/>
-          <p:nvPr/>
-        </p:nvSpPr>
-        <p:spPr>
-          <a:xfrm>
-            <a:off x="2505456" y="7936992"/>
-            <a:ext cx="4599432" cy="420624"/>
+          <p:cNvPr id="52" name="Text 49"/>
+          <p:cNvSpPr/>
+          <p:nvPr/>
+        </p:nvSpPr>
+        <p:spPr>
+          <a:xfrm>
+            <a:off x="2505456" y="7863840"/>
+            <a:ext cx="4599432" cy="402336"/>
           </a:xfrm>
           <a:prstGeom prst="rect">
             <a:avLst/>
@@ -2670,14 +2771,14 @@
       </p:sp>
       <p:sp>
         <p:nvSpPr>
-          <p:cNvPr id="50" name="Shape 47"/>
-          <p:cNvSpPr/>
-          <p:nvPr/>
-        </p:nvSpPr>
-        <p:spPr>
-          <a:xfrm>
-            <a:off x="457200" y="8453628"/>
-            <a:ext cx="41148" cy="132588"/>
+          <p:cNvPr id="53" name="Shape 50"/>
+          <p:cNvSpPr/>
+          <p:nvPr/>
+        </p:nvSpPr>
+        <p:spPr>
+          <a:xfrm>
+            <a:off x="457200" y="8321040"/>
+            <a:ext cx="41148" cy="128016"/>
           </a:xfrm>
           <a:prstGeom prst="rect">
             <a:avLst/>
@@ -2690,13 +2791,13 @@
       </p:sp>
       <p:sp>
         <p:nvSpPr>
-          <p:cNvPr id="51" name="Text 48"/>
-          <p:cNvSpPr/>
-          <p:nvPr/>
-        </p:nvSpPr>
-        <p:spPr>
-          <a:xfrm>
-            <a:off x="585216" y="8412480"/>
+          <p:cNvPr id="54" name="Text 51"/>
+          <p:cNvSpPr/>
+          <p:nvPr/>
+        </p:nvSpPr>
+        <p:spPr>
+          <a:xfrm>
+            <a:off x="585216" y="8284464"/>
             <a:ext cx="1874520" cy="201168"/>
           </a:xfrm>
           <a:prstGeom prst="rect">
@@ -2729,14 +2830,14 @@
       </p:sp>
       <p:sp>
         <p:nvSpPr>
-          <p:cNvPr id="52" name="Text 49"/>
-          <p:cNvSpPr/>
-          <p:nvPr/>
-        </p:nvSpPr>
-        <p:spPr>
-          <a:xfrm>
-            <a:off x="2505456" y="8412480"/>
-            <a:ext cx="4599432" cy="420624"/>
+          <p:cNvPr id="55" name="Text 52"/>
+          <p:cNvSpPr/>
+          <p:nvPr/>
+        </p:nvSpPr>
+        <p:spPr>
+          <a:xfrm>
+            <a:off x="2505456" y="8284464"/>
+            <a:ext cx="4599432" cy="402336"/>
           </a:xfrm>
           <a:prstGeom prst="rect">
             <a:avLst/>
@@ -2763,7 +2864,7 @@
                 <a:ea typeface="Arial" pitchFamily="34" charset="-122"/>
                 <a:cs typeface="Arial" pitchFamily="34" charset="-120"/>
               </a:rPr>
-              <a:t>Three development areas and three strengths, converted into keep, stop and start strategies that are effective, actionable and observable, then disclosed to the team.</a:t>
+              <a:t>Three leadership behaviours to sustain and three to adapt, converted into keep, stop and start strategies that are effective, actionable and observable, then disclosed to the team.</a:t>
             </a:r>
             <a:endParaRPr lang="en-US" sz="820" dirty="0"/>
           </a:p>
@@ -2771,18 +2872,18 @@
       </p:sp>
       <p:sp>
         <p:nvSpPr>
-          <p:cNvPr id="53" name="Shape 50"/>
-          <p:cNvSpPr/>
-          <p:nvPr/>
-        </p:nvSpPr>
-        <p:spPr>
-          <a:xfrm>
-            <a:off x="457200" y="8997696"/>
-            <a:ext cx="6647688" cy="950976"/>
+          <p:cNvPr id="56" name="Shape 53"/>
+          <p:cNvSpPr/>
+          <p:nvPr/>
+        </p:nvSpPr>
+        <p:spPr>
+          <a:xfrm>
+            <a:off x="457200" y="8741664"/>
+            <a:ext cx="6647688" cy="822960"/>
           </a:xfrm>
           <a:prstGeom prst="roundRect">
             <a:avLst>
-              <a:gd name="adj" fmla="val 5769"/>
+              <a:gd name="adj" fmla="val 6667"/>
             </a:avLst>
           </a:prstGeom>
           <a:solidFill>
@@ -2795,13 +2896,13 @@
       </p:sp>
       <p:sp>
         <p:nvSpPr>
-          <p:cNvPr id="54" name="Text 51"/>
-          <p:cNvSpPr/>
-          <p:nvPr/>
-        </p:nvSpPr>
-        <p:spPr>
-          <a:xfrm>
-            <a:off x="658368" y="9089136"/>
+          <p:cNvPr id="57" name="Text 54"/>
+          <p:cNvSpPr/>
+          <p:nvPr/>
+        </p:nvSpPr>
+        <p:spPr>
+          <a:xfrm>
+            <a:off x="658368" y="8805672"/>
             <a:ext cx="6245352" cy="182880"/>
           </a:xfrm>
           <a:prstGeom prst="rect">
@@ -2834,14 +2935,14 @@
       </p:sp>
       <p:sp>
         <p:nvSpPr>
-          <p:cNvPr id="55" name="Text 52"/>
-          <p:cNvSpPr/>
-          <p:nvPr/>
-        </p:nvSpPr>
-        <p:spPr>
-          <a:xfrm>
-            <a:off x="658368" y="9272016"/>
-            <a:ext cx="3031236" cy="283464"/>
+          <p:cNvPr id="58" name="Text 55"/>
+          <p:cNvSpPr/>
+          <p:nvPr/>
+        </p:nvSpPr>
+        <p:spPr>
+          <a:xfrm>
+            <a:off x="658368" y="9006840"/>
+            <a:ext cx="3031236" cy="246888"/>
           </a:xfrm>
           <a:prstGeom prst="rect">
             <a:avLst/>
@@ -2866,7 +2967,7 @@
                 <a:ea typeface="Arial" pitchFamily="34" charset="-122"/>
                 <a:cs typeface="Arial" pitchFamily="34" charset="-120"/>
               </a:rPr>
-              <a:t>Leadership behaviour observed under real load rather than self-reported.</a:t>
+              <a:t>Leadership behaviour assessed under real load, not self-reported.</a:t>
             </a:r>
             <a:endParaRPr lang="en-US" sz="810" dirty="0"/>
           </a:p>
@@ -2874,14 +2975,14 @@
       </p:sp>
       <p:sp>
         <p:nvSpPr>
-          <p:cNvPr id="56" name="Text 53"/>
-          <p:cNvSpPr/>
-          <p:nvPr/>
-        </p:nvSpPr>
-        <p:spPr>
-          <a:xfrm>
-            <a:off x="3872484" y="9272016"/>
-            <a:ext cx="3031236" cy="283464"/>
+          <p:cNvPr id="59" name="Text 56"/>
+          <p:cNvSpPr/>
+          <p:nvPr/>
+        </p:nvSpPr>
+        <p:spPr>
+          <a:xfrm>
+            <a:off x="3872484" y="9006840"/>
+            <a:ext cx="3031236" cy="246888"/>
           </a:xfrm>
           <a:prstGeom prst="rect">
             <a:avLst/>
@@ -2914,14 +3015,14 @@
       </p:sp>
       <p:sp>
         <p:nvSpPr>
-          <p:cNvPr id="57" name="Text 54"/>
-          <p:cNvSpPr/>
-          <p:nvPr/>
-        </p:nvSpPr>
-        <p:spPr>
-          <a:xfrm>
-            <a:off x="658368" y="9573768"/>
-            <a:ext cx="3031236" cy="283464"/>
+          <p:cNvPr id="60" name="Text 57"/>
+          <p:cNvSpPr/>
+          <p:nvPr/>
+        </p:nvSpPr>
+        <p:spPr>
+          <a:xfrm>
+            <a:off x="658368" y="9272016"/>
+            <a:ext cx="3031236" cy="246888"/>
           </a:xfrm>
           <a:prstGeom prst="rect">
             <a:avLst/>
@@ -2946,7 +3047,7 @@
                 <a:ea typeface="Arial" pitchFamily="34" charset="-122"/>
                 <a:cs typeface="Arial" pitchFamily="34" charset="-120"/>
               </a:rPr>
-              <a:t>Every participant returns with a written, observable development plan.</a:t>
+              <a:t>Every leader returns with a written plan for behavioural adaptation.</a:t>
             </a:r>
             <a:endParaRPr lang="en-US" sz="810" dirty="0"/>
           </a:p>
@@ -2954,14 +3055,14 @@
       </p:sp>
       <p:sp>
         <p:nvSpPr>
-          <p:cNvPr id="58" name="Text 55"/>
-          <p:cNvSpPr/>
-          <p:nvPr/>
-        </p:nvSpPr>
-        <p:spPr>
-          <a:xfrm>
-            <a:off x="3872484" y="9573768"/>
-            <a:ext cx="3031236" cy="283464"/>
+          <p:cNvPr id="61" name="Text 58"/>
+          <p:cNvSpPr/>
+          <p:nvPr/>
+        </p:nvSpPr>
+        <p:spPr>
+          <a:xfrm>
+            <a:off x="3872484" y="9272016"/>
+            <a:ext cx="3031236" cy="246888"/>
           </a:xfrm>
           <a:prstGeom prst="rect">
             <a:avLst/>
@@ -2986,7 +3087,7 @@
                 <a:ea typeface="Arial" pitchFamily="34" charset="-122"/>
                 <a:cs typeface="Arial" pitchFamily="34" charset="-120"/>
               </a:rPr>
-              <a:t>Nested in the NZDF Leadership Framework from Lead Self to Lead Organisation.</a:t>
+              <a:t>Nested in the NZDF Leadership Framework, Lead Self to Lead Organisation.</a:t>
             </a:r>
             <a:endParaRPr lang="en-US" sz="810" dirty="0"/>
           </a:p>
@@ -2994,14 +3095,39 @@
       </p:sp>
       <p:sp>
         <p:nvSpPr>
-          <p:cNvPr id="59" name="Text 56"/>
-          <p:cNvSpPr/>
-          <p:nvPr/>
-        </p:nvSpPr>
-        <p:spPr>
-          <a:xfrm>
-            <a:off x="457200" y="10058400"/>
-            <a:ext cx="6647688" cy="384048"/>
+          <p:cNvPr id="62" name="Shape 59"/>
+          <p:cNvSpPr/>
+          <p:nvPr/>
+        </p:nvSpPr>
+        <p:spPr>
+          <a:xfrm>
+            <a:off x="457200" y="9656064"/>
+            <a:ext cx="6647688" cy="493776"/>
+          </a:xfrm>
+          <a:prstGeom prst="rect">
+            <a:avLst/>
+          </a:prstGeom>
+          <a:solidFill>
+            <a:srgbClr val="FFFFFF"/>
+          </a:solidFill>
+          <a:ln w="9525">
+            <a:solidFill>
+              <a:srgbClr val="002516"/>
+            </a:solidFill>
+            <a:prstDash val="solid"/>
+          </a:ln>
+        </p:spPr>
+      </p:sp>
+      <p:sp>
+        <p:nvSpPr>
+          <p:cNvPr id="63" name="Text 60"/>
+          <p:cNvSpPr/>
+          <p:nvPr/>
+        </p:nvSpPr>
+        <p:spPr>
+          <a:xfrm>
+            <a:off x="621792" y="9720072"/>
+            <a:ext cx="6318504" cy="384048"/>
           </a:xfrm>
           <a:prstGeom prst="rect">
             <a:avLst/>
@@ -3020,7 +3146,7 @@
               <a:buNone/>
             </a:pPr>
             <a:r>
-              <a:rPr lang="en-US" sz="860" b="1" dirty="0">
+              <a:rPr lang="en-US" sz="820" b="1" spc="60" kern="0" dirty="0">
                 <a:solidFill>
                   <a:srgbClr val="002516"/>
                 </a:solidFill>
@@ -3028,7 +3154,7 @@
                 <a:ea typeface="Arial" pitchFamily="34" charset="-122"/>
                 <a:cs typeface="Arial" pitchFamily="34" charset="-120"/>
               </a:rPr>
-              <a:t>Next step.  </a:t>
+              <a:t>DELIVERED BY THE NZ ARMY LEADERSHIP CENTRE.  </a:t>
             </a:r>
             <a:pPr algn="l" indent="0" marL="0">
               <a:lnSpc>
@@ -3037,6 +3163,48 @@
               <a:buNone/>
             </a:pPr>
             <a:r>
+              <a:rPr lang="en-US" sz="820" dirty="0">
+                <a:solidFill>
+                  <a:srgbClr val="000000"/>
+                </a:solidFill>
+                <a:latin typeface="Arial" pitchFamily="34" charset="0"/>
+                <a:ea typeface="Arial" pitchFamily="34" charset="-122"/>
+                <a:cs typeface="Arial" pitchFamily="34" charset="-120"/>
+              </a:rPr>
+              <a:t>ELDA Command is developed and delivered by the NZ Army Leadership Centre as part of the Army Command School. It integrates validated psychometrics, evidence-based performance psychology and experiential leadership development within the NZDF Leadership Framework.</a:t>
+            </a:r>
+            <a:endParaRPr lang="en-US" sz="820" dirty="0"/>
+          </a:p>
+        </p:txBody>
+      </p:sp>
+      <p:sp>
+        <p:nvSpPr>
+          <p:cNvPr id="64" name="Text 61"/>
+          <p:cNvSpPr/>
+          <p:nvPr/>
+        </p:nvSpPr>
+        <p:spPr>
+          <a:xfrm>
+            <a:off x="457200" y="10222992"/>
+            <a:ext cx="6647688" cy="310896"/>
+          </a:xfrm>
+          <a:prstGeom prst="rect">
+            <a:avLst/>
+          </a:prstGeom>
+          <a:noFill/>
+          <a:ln/>
+        </p:spPr>
+        <p:txBody>
+          <a:bodyPr wrap="square" lIns="0" tIns="0" rIns="0" bIns="0" rtlCol="0" anchor="t"/>
+          <a:lstStyle/>
+          <a:p>
+            <a:pPr algn="l" indent="0" marL="0">
+              <a:lnSpc>
+                <a:spcPct val="110000"/>
+              </a:lnSpc>
+              <a:buNone/>
+            </a:pPr>
+            <a:r>
               <a:rPr lang="en-US" sz="860" dirty="0">
                 <a:solidFill>
                   <a:srgbClr val="000000"/>
@@ -3045,48 +3213,9 @@
                 <a:ea typeface="Arial" pitchFamily="34" charset="-122"/>
                 <a:cs typeface="Arial" pitchFamily="34" charset="-120"/>
               </a:rPr>
-              <a:t>NZALC can scope a serial in New Zealand for 2027. Confirmation is required of participant numbers and rank range, preferred window, activity and terrain, staff and instructor support, psychometric licensing, and cost and logistic arrangements.</a:t>
+              <a:t>NZALC welcomes the opportunity to tailor an ELDA Command serial to 2nd Commando Regiment's operational context and leadership priorities. Initial scoping would confirm participant profile, activity design, delivery model and support requirements.</a:t>
             </a:r>
             <a:endParaRPr lang="en-US" sz="860" dirty="0"/>
-          </a:p>
-        </p:txBody>
-      </p:sp>
-      <p:sp>
-        <p:nvSpPr>
-          <p:cNvPr id="60" name="Text 57"/>
-          <p:cNvSpPr/>
-          <p:nvPr/>
-        </p:nvSpPr>
-        <p:spPr>
-          <a:xfrm>
-            <a:off x="457200" y="10424160"/>
-            <a:ext cx="6647688" cy="164592"/>
-          </a:xfrm>
-          <a:prstGeom prst="rect">
-            <a:avLst/>
-          </a:prstGeom>
-          <a:noFill/>
-          <a:ln/>
-        </p:spPr>
-        <p:txBody>
-          <a:bodyPr wrap="square" lIns="0" tIns="0" rIns="0" bIns="0" rtlCol="0" anchor="ctr"/>
-          <a:lstStyle/>
-          <a:p>
-            <a:pPr algn="r" indent="0" marL="0">
-              <a:buNone/>
-            </a:pPr>
-            <a:r>
-              <a:rPr lang="en-US" sz="700" dirty="0">
-                <a:solidFill>
-                  <a:srgbClr val="7F7F7F"/>
-                </a:solidFill>
-                <a:latin typeface="Arial" pitchFamily="34" charset="0"/>
-                <a:ea typeface="Arial" pitchFamily="34" charset="-122"/>
-                <a:cs typeface="Arial" pitchFamily="34" charset="-120"/>
-              </a:rPr>
-              <a:t>Prepared for 2nd Commando Regiment  |  August 2026</a:t>
-            </a:r>
-            <a:endParaRPr lang="en-US" sz="700" dirty="0"/>
           </a:p>
         </p:txBody>
       </p:sp>

</xml_diff>

<commit_message>
Brevity pass on the ELDA one-pager: 570 words to 383
Removes the italic rationale, whose mechanism the opening paragraph
already carried, and compresses both into three sentences. The aim
becomes a single line in a half-height band, the learning outcomes become
label-only signposts now that the performance cycle explains how they are
achieved, and the content list, closing panels and credibility statement
are each cut to one sentence per item. Font sizes are unchanged and the
space recovered is left as white space.

Co-Authored-By: Claude Fable 5 <noreply@anthropic.com>
Claude-Session: https://claude.ai/code/session_01YLo1WfwUDkbwfJEF3ZNVbB
</commit_message>
<xml_diff>
--- a/output/elda-command-onepager.pptx
+++ b/output/elda-command-onepager.pptx
@@ -1083,8 +1083,8 @@
         </p:nvSpPr>
         <p:spPr>
           <a:xfrm>
-            <a:off x="457200" y="1737360"/>
-            <a:ext cx="6647688" cy="676656"/>
+            <a:off x="457200" y="1792224"/>
+            <a:ext cx="6647688" cy="512064"/>
           </a:xfrm>
           <a:prstGeom prst="rect">
             <a:avLst/>
@@ -1111,7 +1111,7 @@
                 <a:ea typeface="Arial" pitchFamily="34" charset="-122"/>
                 <a:cs typeface="Arial" pitchFamily="34" charset="-120"/>
               </a:rPr>
-              <a:t>ELDA Command develops leaders who can perform, adapt and influence others under operational pressure. Rather than teaching leadership in a classroom, it exposes leadership behaviour through demanding physical, mental and interpersonal challenge, then converts that experience into lasting behavioural change. Every participant leaves with a written Leadership Development Plan grounded in observed behaviour rather than self-perception.</a:t>
+              <a:t>ELDA Command develops leaders to perform, adapt and influence under operational pressure. Participants lead and follow through a demanding physical, mental and interpersonal activity. Observed behaviour, peer feedback and structured reflection are converted into a written Leadership Development Plan.</a:t>
             </a:r>
             <a:endParaRPr lang="en-US" sz="1000" dirty="0"/>
           </a:p>
@@ -1126,73 +1126,11 @@
         <p:spPr>
           <a:xfrm>
             <a:off x="457200" y="2487168"/>
-            <a:ext cx="45720" cy="420624"/>
-          </a:xfrm>
-          <a:prstGeom prst="rect">
-            <a:avLst/>
-          </a:prstGeom>
-          <a:solidFill>
-            <a:srgbClr val="C62026"/>
-          </a:solidFill>
-          <a:ln/>
-        </p:spPr>
-      </p:sp>
-      <p:sp>
-        <p:nvSpPr>
-          <p:cNvPr id="10" name="Text 7"/>
-          <p:cNvSpPr/>
-          <p:nvPr/>
-        </p:nvSpPr>
-        <p:spPr>
-          <a:xfrm>
-            <a:off x="621792" y="2468880"/>
-            <a:ext cx="6483096" cy="475488"/>
-          </a:xfrm>
-          <a:prstGeom prst="rect">
-            <a:avLst/>
-          </a:prstGeom>
-          <a:noFill/>
-          <a:ln/>
-        </p:spPr>
-        <p:txBody>
-          <a:bodyPr wrap="square" lIns="0" tIns="0" rIns="0" bIns="0" rtlCol="0" anchor="t"/>
-          <a:lstStyle/>
-          <a:p>
-            <a:pPr algn="l" indent="0" marL="0">
-              <a:lnSpc>
-                <a:spcPct val="110000"/>
-              </a:lnSpc>
-              <a:buNone/>
-            </a:pPr>
-            <a:r>
-              <a:rPr lang="en-US" sz="960" i="1" dirty="0">
-                <a:solidFill>
-                  <a:srgbClr val="002516"/>
-                </a:solidFill>
-                <a:latin typeface="Arial" pitchFamily="34" charset="0"/>
-                <a:ea typeface="Arial" pitchFamily="34" charset="-122"/>
-                <a:cs typeface="Arial" pitchFamily="34" charset="-120"/>
-              </a:rPr>
-              <a:t>Leadership behaviour is most accurately revealed under sustained pressure, uncertainty and fatigue. ELDA deliberately creates those conditions, then uses structured reflection and peer feedback to convert experience into enduring behavioural change.</a:t>
-            </a:r>
-            <a:endParaRPr lang="en-US" sz="960" dirty="0"/>
-          </a:p>
-        </p:txBody>
-      </p:sp>
-      <p:sp>
-        <p:nvSpPr>
-          <p:cNvPr id="11" name="Shape 8"/>
-          <p:cNvSpPr/>
-          <p:nvPr/>
-        </p:nvSpPr>
-        <p:spPr>
-          <a:xfrm>
-            <a:off x="457200" y="2999232"/>
-            <a:ext cx="6647688" cy="603504"/>
+            <a:ext cx="6647688" cy="402336"/>
           </a:xfrm>
           <a:prstGeom prst="roundRect">
             <a:avLst>
-              <a:gd name="adj" fmla="val 9091"/>
+              <a:gd name="adj" fmla="val 13636"/>
             </a:avLst>
           </a:prstGeom>
           <a:solidFill>
@@ -1203,14 +1141,14 @@
       </p:sp>
       <p:sp>
         <p:nvSpPr>
-          <p:cNvPr id="12" name="Text 9"/>
-          <p:cNvSpPr/>
-          <p:nvPr/>
-        </p:nvSpPr>
-        <p:spPr>
-          <a:xfrm>
-            <a:off x="658368" y="3063240"/>
-            <a:ext cx="1097280" cy="164592"/>
+          <p:cNvPr id="10" name="Text 7"/>
+          <p:cNvSpPr/>
+          <p:nvPr/>
+        </p:nvSpPr>
+        <p:spPr>
+          <a:xfrm>
+            <a:off x="658368" y="2487168"/>
+            <a:ext cx="548640" cy="402336"/>
           </a:xfrm>
           <a:prstGeom prst="rect">
             <a:avLst/>
@@ -1242,56 +1180,14 @@
       </p:sp>
       <p:sp>
         <p:nvSpPr>
-          <p:cNvPr id="13" name="Text 10"/>
-          <p:cNvSpPr/>
-          <p:nvPr/>
-        </p:nvSpPr>
-        <p:spPr>
-          <a:xfrm>
-            <a:off x="658368" y="3236976"/>
-            <a:ext cx="6245352" cy="310896"/>
-          </a:xfrm>
-          <a:prstGeom prst="rect">
-            <a:avLst/>
-          </a:prstGeom>
-          <a:noFill/>
-          <a:ln/>
-        </p:spPr>
-        <p:txBody>
-          <a:bodyPr wrap="square" lIns="0" tIns="0" rIns="0" bIns="0" rtlCol="0" anchor="t"/>
-          <a:lstStyle/>
-          <a:p>
-            <a:pPr algn="l" indent="0" marL="0">
-              <a:lnSpc>
-                <a:spcPct val="110000"/>
-              </a:lnSpc>
-              <a:buNone/>
-            </a:pPr>
-            <a:r>
-              <a:rPr lang="en-US" sz="960" dirty="0">
-                <a:solidFill>
-                  <a:srgbClr val="FFFFFF"/>
-                </a:solidFill>
-                <a:latin typeface="Arial" pitchFamily="34" charset="0"/>
-                <a:ea typeface="Arial" pitchFamily="34" charset="-122"/>
-                <a:cs typeface="Arial" pitchFamily="34" charset="-120"/>
-              </a:rPr>
-              <a:t>To develop leaders who can consistently perform, adapt and influence others under pressure, while strengthening individual effectiveness and collective team performance.</a:t>
-            </a:r>
-            <a:endParaRPr lang="en-US" sz="960" dirty="0"/>
-          </a:p>
-        </p:txBody>
-      </p:sp>
-      <p:sp>
-        <p:nvSpPr>
-          <p:cNvPr id="14" name="Text 11"/>
-          <p:cNvSpPr/>
-          <p:nvPr/>
-        </p:nvSpPr>
-        <p:spPr>
-          <a:xfrm>
-            <a:off x="457200" y="3675888"/>
-            <a:ext cx="6647688" cy="182880"/>
+          <p:cNvPr id="11" name="Text 8"/>
+          <p:cNvSpPr/>
+          <p:nvPr/>
+        </p:nvSpPr>
+        <p:spPr>
+          <a:xfrm>
+            <a:off x="1243584" y="2487168"/>
+            <a:ext cx="5660136" cy="402336"/>
           </a:xfrm>
           <a:prstGeom prst="rect">
             <a:avLst/>
@@ -1307,6 +1203,45 @@
               <a:buNone/>
             </a:pPr>
             <a:r>
+              <a:rPr lang="en-US" sz="960" dirty="0">
+                <a:solidFill>
+                  <a:srgbClr val="FFFFFF"/>
+                </a:solidFill>
+                <a:latin typeface="Arial" pitchFamily="34" charset="0"/>
+                <a:ea typeface="Arial" pitchFamily="34" charset="-122"/>
+                <a:cs typeface="Arial" pitchFamily="34" charset="-120"/>
+              </a:rPr>
+              <a:t>Strengthen individual command effectiveness and collective team performance under pressure.</a:t>
+            </a:r>
+            <a:endParaRPr lang="en-US" sz="960" dirty="0"/>
+          </a:p>
+        </p:txBody>
+      </p:sp>
+      <p:sp>
+        <p:nvSpPr>
+          <p:cNvPr id="12" name="Text 9"/>
+          <p:cNvSpPr/>
+          <p:nvPr/>
+        </p:nvSpPr>
+        <p:spPr>
+          <a:xfrm>
+            <a:off x="457200" y="3108960"/>
+            <a:ext cx="6647688" cy="182880"/>
+          </a:xfrm>
+          <a:prstGeom prst="rect">
+            <a:avLst/>
+          </a:prstGeom>
+          <a:noFill/>
+          <a:ln/>
+        </p:spPr>
+        <p:txBody>
+          <a:bodyPr wrap="square" lIns="0" tIns="0" rIns="0" bIns="0" rtlCol="0" anchor="ctr"/>
+          <a:lstStyle/>
+          <a:p>
+            <a:pPr algn="l" indent="0" marL="0">
+              <a:buNone/>
+            </a:pPr>
+            <a:r>
               <a:rPr lang="en-US" sz="850" b="1" spc="140" kern="0" dirty="0">
                 <a:solidFill>
                   <a:srgbClr val="002516"/>
@@ -1323,18 +1258,18 @@
       </p:sp>
       <p:sp>
         <p:nvSpPr>
-          <p:cNvPr id="15" name="Shape 12"/>
-          <p:cNvSpPr/>
-          <p:nvPr/>
-        </p:nvSpPr>
-        <p:spPr>
-          <a:xfrm>
-            <a:off x="457200" y="3877056"/>
-            <a:ext cx="2130552" cy="694944"/>
+          <p:cNvPr id="13" name="Shape 10"/>
+          <p:cNvSpPr/>
+          <p:nvPr/>
+        </p:nvSpPr>
+        <p:spPr>
+          <a:xfrm>
+            <a:off x="457200" y="3310128"/>
+            <a:ext cx="2130552" cy="420624"/>
           </a:xfrm>
           <a:prstGeom prst="roundRect">
             <a:avLst>
-              <a:gd name="adj" fmla="val 7895"/>
+              <a:gd name="adj" fmla="val 13043"/>
             </a:avLst>
           </a:prstGeom>
           <a:solidFill>
@@ -1352,13 +1287,13 @@
       </p:sp>
       <p:sp>
         <p:nvSpPr>
-          <p:cNvPr id="16" name="Shape 13"/>
-          <p:cNvSpPr/>
-          <p:nvPr/>
-        </p:nvSpPr>
-        <p:spPr>
-          <a:xfrm>
-            <a:off x="585216" y="3968496"/>
+          <p:cNvPr id="14" name="Shape 11"/>
+          <p:cNvSpPr/>
+          <p:nvPr/>
+        </p:nvSpPr>
+        <p:spPr>
+          <a:xfrm>
+            <a:off x="585216" y="3419856"/>
             <a:ext cx="201168" cy="201168"/>
           </a:xfrm>
           <a:prstGeom prst="ellipse">
@@ -1372,13 +1307,13 @@
       </p:sp>
       <p:sp>
         <p:nvSpPr>
-          <p:cNvPr id="17" name="Text 14"/>
-          <p:cNvSpPr/>
-          <p:nvPr/>
-        </p:nvSpPr>
-        <p:spPr>
-          <a:xfrm>
-            <a:off x="585216" y="3968496"/>
+          <p:cNvPr id="15" name="Text 12"/>
+          <p:cNvSpPr/>
+          <p:nvPr/>
+        </p:nvSpPr>
+        <p:spPr>
+          <a:xfrm>
+            <a:off x="585216" y="3419856"/>
             <a:ext cx="201168" cy="201168"/>
           </a:xfrm>
           <a:prstGeom prst="rect">
@@ -1411,14 +1346,14 @@
       </p:sp>
       <p:sp>
         <p:nvSpPr>
-          <p:cNvPr id="18" name="Text 15"/>
-          <p:cNvSpPr/>
-          <p:nvPr/>
-        </p:nvSpPr>
-        <p:spPr>
-          <a:xfrm>
-            <a:off x="841248" y="3968496"/>
-            <a:ext cx="1618488" cy="201168"/>
+          <p:cNvPr id="16" name="Text 13"/>
+          <p:cNvSpPr/>
+          <p:nvPr/>
+        </p:nvSpPr>
+        <p:spPr>
+          <a:xfrm>
+            <a:off x="822960" y="3310128"/>
+            <a:ext cx="1691640" cy="420624"/>
           </a:xfrm>
           <a:prstGeom prst="rect">
             <a:avLst/>
@@ -1434,7 +1369,7 @@
               <a:buNone/>
             </a:pPr>
             <a:r>
-              <a:rPr lang="en-US" sz="860" b="1" dirty="0">
+              <a:rPr lang="en-US" sz="880" b="1" dirty="0">
                 <a:solidFill>
                   <a:srgbClr val="002516"/>
                 </a:solidFill>
@@ -1442,68 +1377,26 @@
                 <a:ea typeface="Arial" pitchFamily="34" charset="-122"/>
                 <a:cs typeface="Arial" pitchFamily="34" charset="-120"/>
               </a:rPr>
-              <a:t>PERFORMANCE MINDSET</a:t>
-            </a:r>
-            <a:endParaRPr lang="en-US" sz="860" dirty="0"/>
-          </a:p>
-        </p:txBody>
-      </p:sp>
-      <p:sp>
-        <p:nvSpPr>
-          <p:cNvPr id="19" name="Text 16"/>
-          <p:cNvSpPr/>
-          <p:nvPr/>
-        </p:nvSpPr>
-        <p:spPr>
-          <a:xfrm>
-            <a:off x="585216" y="4187952"/>
-            <a:ext cx="1874520" cy="365760"/>
-          </a:xfrm>
-          <a:prstGeom prst="rect">
-            <a:avLst/>
-          </a:prstGeom>
-          <a:noFill/>
-          <a:ln/>
-        </p:spPr>
-        <p:txBody>
-          <a:bodyPr wrap="square" lIns="0" tIns="0" rIns="0" bIns="0" rtlCol="0" anchor="t"/>
-          <a:lstStyle/>
-          <a:p>
-            <a:pPr algn="l" indent="0" marL="0">
-              <a:lnSpc>
-                <a:spcPct val="110000"/>
-              </a:lnSpc>
-              <a:buNone/>
-            </a:pPr>
-            <a:r>
-              <a:rPr lang="en-US" sz="840" dirty="0">
-                <a:solidFill>
-                  <a:srgbClr val="000000"/>
-                </a:solidFill>
-                <a:latin typeface="Arial" pitchFamily="34" charset="0"/>
-                <a:ea typeface="Arial" pitchFamily="34" charset="-122"/>
-                <a:cs typeface="Arial" pitchFamily="34" charset="-120"/>
-              </a:rPr>
-              <a:t>Build the mental skills to perform and decide under pressure.</a:t>
-            </a:r>
-            <a:endParaRPr lang="en-US" sz="840" dirty="0"/>
-          </a:p>
-        </p:txBody>
-      </p:sp>
-      <p:sp>
-        <p:nvSpPr>
-          <p:cNvPr id="20" name="Shape 17"/>
-          <p:cNvSpPr/>
-          <p:nvPr/>
-        </p:nvSpPr>
-        <p:spPr>
-          <a:xfrm>
-            <a:off x="2715768" y="3877056"/>
-            <a:ext cx="2130552" cy="694944"/>
+              <a:t>PERFORM UNDER PRESSURE</a:t>
+            </a:r>
+            <a:endParaRPr lang="en-US" sz="880" dirty="0"/>
+          </a:p>
+        </p:txBody>
+      </p:sp>
+      <p:sp>
+        <p:nvSpPr>
+          <p:cNvPr id="17" name="Shape 14"/>
+          <p:cNvSpPr/>
+          <p:nvPr/>
+        </p:nvSpPr>
+        <p:spPr>
+          <a:xfrm>
+            <a:off x="2715768" y="3310128"/>
+            <a:ext cx="2130552" cy="420624"/>
           </a:xfrm>
           <a:prstGeom prst="roundRect">
             <a:avLst>
-              <a:gd name="adj" fmla="val 7895"/>
+              <a:gd name="adj" fmla="val 13043"/>
             </a:avLst>
           </a:prstGeom>
           <a:solidFill>
@@ -1521,13 +1414,13 @@
       </p:sp>
       <p:sp>
         <p:nvSpPr>
-          <p:cNvPr id="21" name="Shape 18"/>
-          <p:cNvSpPr/>
-          <p:nvPr/>
-        </p:nvSpPr>
-        <p:spPr>
-          <a:xfrm>
-            <a:off x="2843784" y="3968496"/>
+          <p:cNvPr id="18" name="Shape 15"/>
+          <p:cNvSpPr/>
+          <p:nvPr/>
+        </p:nvSpPr>
+        <p:spPr>
+          <a:xfrm>
+            <a:off x="2843784" y="3419856"/>
             <a:ext cx="201168" cy="201168"/>
           </a:xfrm>
           <a:prstGeom prst="ellipse">
@@ -1541,13 +1434,13 @@
       </p:sp>
       <p:sp>
         <p:nvSpPr>
-          <p:cNvPr id="22" name="Text 19"/>
-          <p:cNvSpPr/>
-          <p:nvPr/>
-        </p:nvSpPr>
-        <p:spPr>
-          <a:xfrm>
-            <a:off x="2843784" y="3968496"/>
+          <p:cNvPr id="19" name="Text 16"/>
+          <p:cNvSpPr/>
+          <p:nvPr/>
+        </p:nvSpPr>
+        <p:spPr>
+          <a:xfrm>
+            <a:off x="2843784" y="3419856"/>
             <a:ext cx="201168" cy="201168"/>
           </a:xfrm>
           <a:prstGeom prst="rect">
@@ -1580,14 +1473,14 @@
       </p:sp>
       <p:sp>
         <p:nvSpPr>
-          <p:cNvPr id="23" name="Text 20"/>
-          <p:cNvSpPr/>
-          <p:nvPr/>
-        </p:nvSpPr>
-        <p:spPr>
-          <a:xfrm>
-            <a:off x="3099816" y="3968496"/>
-            <a:ext cx="1618488" cy="201168"/>
+          <p:cNvPr id="20" name="Text 17"/>
+          <p:cNvSpPr/>
+          <p:nvPr/>
+        </p:nvSpPr>
+        <p:spPr>
+          <a:xfrm>
+            <a:off x="3081528" y="3310128"/>
+            <a:ext cx="1691640" cy="420624"/>
           </a:xfrm>
           <a:prstGeom prst="rect">
             <a:avLst/>
@@ -1603,7 +1496,7 @@
               <a:buNone/>
             </a:pPr>
             <a:r>
-              <a:rPr lang="en-US" sz="860" b="1" dirty="0">
+              <a:rPr lang="en-US" sz="880" b="1" dirty="0">
                 <a:solidFill>
                   <a:srgbClr val="002516"/>
                 </a:solidFill>
@@ -1611,68 +1504,26 @@
                 <a:ea typeface="Arial" pitchFamily="34" charset="-122"/>
                 <a:cs typeface="Arial" pitchFamily="34" charset="-120"/>
               </a:rPr>
-              <a:t>THE ACTIVITY</a:t>
-            </a:r>
-            <a:endParaRPr lang="en-US" sz="860" dirty="0"/>
-          </a:p>
-        </p:txBody>
-      </p:sp>
-      <p:sp>
-        <p:nvSpPr>
-          <p:cNvPr id="24" name="Text 21"/>
-          <p:cNvSpPr/>
-          <p:nvPr/>
-        </p:nvSpPr>
-        <p:spPr>
-          <a:xfrm>
-            <a:off x="2843784" y="4187952"/>
-            <a:ext cx="1874520" cy="365760"/>
-          </a:xfrm>
-          <a:prstGeom prst="rect">
-            <a:avLst/>
-          </a:prstGeom>
-          <a:noFill/>
-          <a:ln/>
-        </p:spPr>
-        <p:txBody>
-          <a:bodyPr wrap="square" lIns="0" tIns="0" rIns="0" bIns="0" rtlCol="0" anchor="t"/>
-          <a:lstStyle/>
-          <a:p>
-            <a:pPr algn="l" indent="0" marL="0">
-              <a:lnSpc>
-                <a:spcPct val="110000"/>
-              </a:lnSpc>
-              <a:buNone/>
-            </a:pPr>
-            <a:r>
-              <a:rPr lang="en-US" sz="840" dirty="0">
-                <a:solidFill>
-                  <a:srgbClr val="000000"/>
-                </a:solidFill>
-                <a:latin typeface="Arial" pitchFamily="34" charset="0"/>
-                <a:ea typeface="Arial" pitchFamily="34" charset="-122"/>
-                <a:cs typeface="Arial" pitchFamily="34" charset="-120"/>
-              </a:rPr>
-              <a:t>Lead and follow through a genuinely demanding serial.</a:t>
-            </a:r>
-            <a:endParaRPr lang="en-US" sz="840" dirty="0"/>
-          </a:p>
-        </p:txBody>
-      </p:sp>
-      <p:sp>
-        <p:nvSpPr>
-          <p:cNvPr id="25" name="Shape 22"/>
-          <p:cNvSpPr/>
-          <p:nvPr/>
-        </p:nvSpPr>
-        <p:spPr>
-          <a:xfrm>
-            <a:off x="4974336" y="3877056"/>
-            <a:ext cx="2130552" cy="694944"/>
+              <a:t>LEAD UNDER LOAD</a:t>
+            </a:r>
+            <a:endParaRPr lang="en-US" sz="880" dirty="0"/>
+          </a:p>
+        </p:txBody>
+      </p:sp>
+      <p:sp>
+        <p:nvSpPr>
+          <p:cNvPr id="21" name="Shape 18"/>
+          <p:cNvSpPr/>
+          <p:nvPr/>
+        </p:nvSpPr>
+        <p:spPr>
+          <a:xfrm>
+            <a:off x="4974336" y="3310128"/>
+            <a:ext cx="2130552" cy="420624"/>
           </a:xfrm>
           <a:prstGeom prst="roundRect">
             <a:avLst>
-              <a:gd name="adj" fmla="val 7895"/>
+              <a:gd name="adj" fmla="val 13043"/>
             </a:avLst>
           </a:prstGeom>
           <a:solidFill>
@@ -1690,13 +1541,13 @@
       </p:sp>
       <p:sp>
         <p:nvSpPr>
-          <p:cNvPr id="26" name="Shape 23"/>
-          <p:cNvSpPr/>
-          <p:nvPr/>
-        </p:nvSpPr>
-        <p:spPr>
-          <a:xfrm>
-            <a:off x="5102352" y="3968496"/>
+          <p:cNvPr id="22" name="Shape 19"/>
+          <p:cNvSpPr/>
+          <p:nvPr/>
+        </p:nvSpPr>
+        <p:spPr>
+          <a:xfrm>
+            <a:off x="5102352" y="3419856"/>
             <a:ext cx="201168" cy="201168"/>
           </a:xfrm>
           <a:prstGeom prst="ellipse">
@@ -1710,13 +1561,13 @@
       </p:sp>
       <p:sp>
         <p:nvSpPr>
-          <p:cNvPr id="27" name="Text 24"/>
-          <p:cNvSpPr/>
-          <p:nvPr/>
-        </p:nvSpPr>
-        <p:spPr>
-          <a:xfrm>
-            <a:off x="5102352" y="3968496"/>
+          <p:cNvPr id="23" name="Text 20"/>
+          <p:cNvSpPr/>
+          <p:nvPr/>
+        </p:nvSpPr>
+        <p:spPr>
+          <a:xfrm>
+            <a:off x="5102352" y="3419856"/>
             <a:ext cx="201168" cy="201168"/>
           </a:xfrm>
           <a:prstGeom prst="rect">
@@ -1749,14 +1600,14 @@
       </p:sp>
       <p:sp>
         <p:nvSpPr>
-          <p:cNvPr id="28" name="Text 25"/>
-          <p:cNvSpPr/>
-          <p:nvPr/>
-        </p:nvSpPr>
-        <p:spPr>
-          <a:xfrm>
-            <a:off x="5358384" y="3968496"/>
-            <a:ext cx="1618488" cy="201168"/>
+          <p:cNvPr id="24" name="Text 21"/>
+          <p:cNvSpPr/>
+          <p:nvPr/>
+        </p:nvSpPr>
+        <p:spPr>
+          <a:xfrm>
+            <a:off x="5340096" y="3310128"/>
+            <a:ext cx="1691640" cy="420624"/>
           </a:xfrm>
           <a:prstGeom prst="rect">
             <a:avLst/>
@@ -1772,7 +1623,7 @@
               <a:buNone/>
             </a:pPr>
             <a:r>
-              <a:rPr lang="en-US" sz="860" b="1" dirty="0">
+              <a:rPr lang="en-US" sz="880" b="1" dirty="0">
                 <a:solidFill>
                   <a:srgbClr val="002516"/>
                 </a:solidFill>
@@ -1780,22 +1631,618 @@
                 <a:ea typeface="Arial" pitchFamily="34" charset="-122"/>
                 <a:cs typeface="Arial" pitchFamily="34" charset="-120"/>
               </a:rPr>
-              <a:t>DEVELOPMENT PLAN</a:t>
-            </a:r>
-            <a:endParaRPr lang="en-US" sz="860" dirty="0"/>
-          </a:p>
-        </p:txBody>
-      </p:sp>
-      <p:sp>
-        <p:nvSpPr>
-          <p:cNvPr id="29" name="Text 26"/>
-          <p:cNvSpPr/>
-          <p:nvPr/>
-        </p:nvSpPr>
-        <p:spPr>
-          <a:xfrm>
-            <a:off x="5102352" y="4187952"/>
-            <a:ext cx="1874520" cy="365760"/>
+              <a:t>ADAPT BEHAVIOUR</a:t>
+            </a:r>
+            <a:endParaRPr lang="en-US" sz="880" dirty="0"/>
+          </a:p>
+        </p:txBody>
+      </p:sp>
+      <p:sp>
+        <p:nvSpPr>
+          <p:cNvPr id="25" name="Text 22"/>
+          <p:cNvSpPr/>
+          <p:nvPr/>
+        </p:nvSpPr>
+        <p:spPr>
+          <a:xfrm>
+            <a:off x="457200" y="3986784"/>
+            <a:ext cx="6647688" cy="182880"/>
+          </a:xfrm>
+          <a:prstGeom prst="rect">
+            <a:avLst/>
+          </a:prstGeom>
+          <a:noFill/>
+          <a:ln/>
+        </p:spPr>
+        <p:txBody>
+          <a:bodyPr wrap="square" lIns="0" tIns="0" rIns="0" bIns="0" rtlCol="0" anchor="ctr"/>
+          <a:lstStyle/>
+          <a:p>
+            <a:pPr algn="l" indent="0" marL="0">
+              <a:buNone/>
+            </a:pPr>
+            <a:r>
+              <a:rPr lang="en-US" sz="850" b="1" spc="140" kern="0" dirty="0">
+                <a:solidFill>
+                  <a:srgbClr val="002516"/>
+                </a:solidFill>
+                <a:latin typeface="Arial" pitchFamily="34" charset="0"/>
+                <a:ea typeface="Arial" pitchFamily="34" charset="-122"/>
+                <a:cs typeface="Arial" pitchFamily="34" charset="-120"/>
+              </a:rPr>
+              <a:t>THE PERFORMANCE CYCLE</a:t>
+            </a:r>
+            <a:endParaRPr lang="en-US" sz="850" dirty="0"/>
+          </a:p>
+        </p:txBody>
+      </p:sp>
+      <p:sp>
+        <p:nvSpPr>
+          <p:cNvPr id="26" name="Shape 23"/>
+          <p:cNvSpPr/>
+          <p:nvPr/>
+        </p:nvSpPr>
+        <p:spPr>
+          <a:xfrm>
+            <a:off x="457200" y="4187952"/>
+            <a:ext cx="2130552" cy="256032"/>
+          </a:xfrm>
+          <a:prstGeom prst="rect">
+            <a:avLst/>
+          </a:prstGeom>
+          <a:solidFill>
+            <a:srgbClr val="002516"/>
+          </a:solidFill>
+          <a:ln/>
+        </p:spPr>
+      </p:sp>
+      <p:sp>
+        <p:nvSpPr>
+          <p:cNvPr id="27" name="Text 24"/>
+          <p:cNvSpPr/>
+          <p:nvPr/>
+        </p:nvSpPr>
+        <p:spPr>
+          <a:xfrm>
+            <a:off x="457200" y="4187952"/>
+            <a:ext cx="2130552" cy="256032"/>
+          </a:xfrm>
+          <a:prstGeom prst="rect">
+            <a:avLst/>
+          </a:prstGeom>
+          <a:noFill/>
+          <a:ln/>
+        </p:spPr>
+        <p:txBody>
+          <a:bodyPr wrap="square" lIns="0" tIns="0" rIns="0" bIns="0" rtlCol="0" anchor="ctr"/>
+          <a:lstStyle/>
+          <a:p>
+            <a:pPr algn="ctr" indent="0" marL="0">
+              <a:buNone/>
+            </a:pPr>
+            <a:r>
+              <a:rPr lang="en-US" sz="950" b="1" spc="160" kern="0" dirty="0">
+                <a:solidFill>
+                  <a:srgbClr val="FFFFFF"/>
+                </a:solidFill>
+                <a:latin typeface="Arial" pitchFamily="34" charset="0"/>
+                <a:ea typeface="Arial" pitchFamily="34" charset="-122"/>
+                <a:cs typeface="Arial" pitchFamily="34" charset="-120"/>
+              </a:rPr>
+              <a:t>PREPARE</a:t>
+            </a:r>
+            <a:endParaRPr lang="en-US" sz="950" dirty="0"/>
+          </a:p>
+        </p:txBody>
+      </p:sp>
+      <p:sp>
+        <p:nvSpPr>
+          <p:cNvPr id="28" name="Text 25"/>
+          <p:cNvSpPr/>
+          <p:nvPr/>
+        </p:nvSpPr>
+        <p:spPr>
+          <a:xfrm>
+            <a:off x="475488" y="4517136"/>
+            <a:ext cx="2093976" cy="969264"/>
+          </a:xfrm>
+          <a:prstGeom prst="rect">
+            <a:avLst/>
+          </a:prstGeom>
+          <a:noFill/>
+          <a:ln/>
+        </p:spPr>
+        <p:txBody>
+          <a:bodyPr wrap="square" lIns="0" tIns="0" rIns="0" bIns="0" rtlCol="0" anchor="t"/>
+          <a:lstStyle/>
+          <a:p>
+            <a:pPr algn="l" marL="127000" indent="-127000">
+              <a:lnSpc>
+                <a:spcPct val="110000"/>
+              </a:lnSpc>
+              <a:spcAft>
+                <a:spcPts val="500"/>
+              </a:spcAft>
+              <a:buSzPct val="100000"/>
+              <a:buChar char="•"/>
+            </a:pPr>
+            <a:r>
+              <a:rPr lang="en-US" sz="820" dirty="0">
+                <a:solidFill>
+                  <a:srgbClr val="000000"/>
+                </a:solidFill>
+                <a:latin typeface="Arial" pitchFamily="34" charset="0"/>
+                <a:ea typeface="Arial" pitchFamily="34" charset="-122"/>
+                <a:cs typeface="Arial" pitchFamily="34" charset="-120"/>
+              </a:rPr>
+              <a:t>Profile everyday and under-pressure behaviour and personal drivers.</a:t>
+            </a:r>
+            <a:endParaRPr lang="en-US" sz="820" dirty="0"/>
+          </a:p>
+          <a:p>
+            <a:pPr algn="l" marL="127000" indent="-127000">
+              <a:lnSpc>
+                <a:spcPct val="110000"/>
+              </a:lnSpc>
+              <a:spcAft>
+                <a:spcPts val="500"/>
+              </a:spcAft>
+              <a:buSzPct val="100000"/>
+              <a:buChar char="•"/>
+            </a:pPr>
+            <a:r>
+              <a:rPr lang="en-US" sz="820" dirty="0">
+                <a:solidFill>
+                  <a:srgbClr val="000000"/>
+                </a:solidFill>
+                <a:latin typeface="Arial" pitchFamily="34" charset="0"/>
+                <a:ea typeface="Arial" pitchFamily="34" charset="-122"/>
+                <a:cs typeface="Arial" pitchFamily="34" charset="-120"/>
+              </a:rPr>
+              <a:t>Identify behaviours that will help or hinder performance.</a:t>
+            </a:r>
+            <a:endParaRPr lang="en-US" sz="820" dirty="0"/>
+          </a:p>
+          <a:p>
+            <a:pPr algn="l" marL="127000" indent="-127000">
+              <a:lnSpc>
+                <a:spcPct val="110000"/>
+              </a:lnSpc>
+              <a:spcAft>
+                <a:spcPts val="500"/>
+              </a:spcAft>
+              <a:buSzPct val="100000"/>
+              <a:buChar char="•"/>
+            </a:pPr>
+            <a:r>
+              <a:rPr lang="en-US" sz="820" dirty="0">
+                <a:solidFill>
+                  <a:srgbClr val="000000"/>
+                </a:solidFill>
+                <a:latin typeface="Arial" pitchFamily="34" charset="0"/>
+                <a:ea typeface="Arial" pitchFamily="34" charset="-122"/>
+                <a:cs typeface="Arial" pitchFamily="34" charset="-120"/>
+              </a:rPr>
+              <a:t>Select mental skills for the activity.</a:t>
+            </a:r>
+            <a:endParaRPr lang="en-US" sz="820" dirty="0"/>
+          </a:p>
+        </p:txBody>
+      </p:sp>
+      <p:sp>
+        <p:nvSpPr>
+          <p:cNvPr id="29" name="Shape 26"/>
+          <p:cNvSpPr/>
+          <p:nvPr/>
+        </p:nvSpPr>
+        <p:spPr>
+          <a:xfrm>
+            <a:off x="2715768" y="4187952"/>
+            <a:ext cx="2130552" cy="256032"/>
+          </a:xfrm>
+          <a:prstGeom prst="rect">
+            <a:avLst/>
+          </a:prstGeom>
+          <a:solidFill>
+            <a:srgbClr val="3A4B00"/>
+          </a:solidFill>
+          <a:ln/>
+        </p:spPr>
+      </p:sp>
+      <p:sp>
+        <p:nvSpPr>
+          <p:cNvPr id="30" name="Text 27"/>
+          <p:cNvSpPr/>
+          <p:nvPr/>
+        </p:nvSpPr>
+        <p:spPr>
+          <a:xfrm>
+            <a:off x="2715768" y="4187952"/>
+            <a:ext cx="2130552" cy="256032"/>
+          </a:xfrm>
+          <a:prstGeom prst="rect">
+            <a:avLst/>
+          </a:prstGeom>
+          <a:noFill/>
+          <a:ln/>
+        </p:spPr>
+        <p:txBody>
+          <a:bodyPr wrap="square" lIns="0" tIns="0" rIns="0" bIns="0" rtlCol="0" anchor="ctr"/>
+          <a:lstStyle/>
+          <a:p>
+            <a:pPr algn="ctr" indent="0" marL="0">
+              <a:buNone/>
+            </a:pPr>
+            <a:r>
+              <a:rPr lang="en-US" sz="950" b="1" spc="160" kern="0" dirty="0">
+                <a:solidFill>
+                  <a:srgbClr val="FFFFFF"/>
+                </a:solidFill>
+                <a:latin typeface="Arial" pitchFamily="34" charset="0"/>
+                <a:ea typeface="Arial" pitchFamily="34" charset="-122"/>
+                <a:cs typeface="Arial" pitchFamily="34" charset="-120"/>
+              </a:rPr>
+              <a:t>PERFORM</a:t>
+            </a:r>
+            <a:endParaRPr lang="en-US" sz="950" dirty="0"/>
+          </a:p>
+        </p:txBody>
+      </p:sp>
+      <p:sp>
+        <p:nvSpPr>
+          <p:cNvPr id="31" name="Text 28"/>
+          <p:cNvSpPr/>
+          <p:nvPr/>
+        </p:nvSpPr>
+        <p:spPr>
+          <a:xfrm>
+            <a:off x="2734056" y="4517136"/>
+            <a:ext cx="2093976" cy="969264"/>
+          </a:xfrm>
+          <a:prstGeom prst="rect">
+            <a:avLst/>
+          </a:prstGeom>
+          <a:noFill/>
+          <a:ln/>
+        </p:spPr>
+        <p:txBody>
+          <a:bodyPr wrap="square" lIns="0" tIns="0" rIns="0" bIns="0" rtlCol="0" anchor="t"/>
+          <a:lstStyle/>
+          <a:p>
+            <a:pPr algn="l" marL="127000" indent="-127000">
+              <a:lnSpc>
+                <a:spcPct val="110000"/>
+              </a:lnSpc>
+              <a:spcAft>
+                <a:spcPts val="500"/>
+              </a:spcAft>
+              <a:buSzPct val="100000"/>
+              <a:buChar char="•"/>
+            </a:pPr>
+            <a:r>
+              <a:rPr lang="en-US" sz="820" dirty="0">
+                <a:solidFill>
+                  <a:srgbClr val="000000"/>
+                </a:solidFill>
+                <a:latin typeface="Arial" pitchFamily="34" charset="0"/>
+                <a:ea typeface="Arial" pitchFamily="34" charset="-122"/>
+                <a:cs typeface="Arial" pitchFamily="34" charset="-120"/>
+              </a:rPr>
+              <a:t>Lead and follow as a team under sustained physical and mental load.</a:t>
+            </a:r>
+            <a:endParaRPr lang="en-US" sz="820" dirty="0"/>
+          </a:p>
+          <a:p>
+            <a:pPr algn="l" marL="127000" indent="-127000">
+              <a:lnSpc>
+                <a:spcPct val="110000"/>
+              </a:lnSpc>
+              <a:spcAft>
+                <a:spcPts val="500"/>
+              </a:spcAft>
+              <a:buSzPct val="100000"/>
+              <a:buChar char="•"/>
+            </a:pPr>
+            <a:r>
+              <a:rPr lang="en-US" sz="820" dirty="0">
+                <a:solidFill>
+                  <a:srgbClr val="000000"/>
+                </a:solidFill>
+                <a:latin typeface="Arial" pitchFamily="34" charset="0"/>
+                <a:ea typeface="Arial" pitchFamily="34" charset="-122"/>
+                <a:cs typeface="Arial" pitchFamily="34" charset="-120"/>
+              </a:rPr>
+              <a:t>Apply selected behaviours and mental skills in real time.</a:t>
+            </a:r>
+            <a:endParaRPr lang="en-US" sz="820" dirty="0"/>
+          </a:p>
+          <a:p>
+            <a:pPr algn="l" marL="127000" indent="-127000">
+              <a:lnSpc>
+                <a:spcPct val="110000"/>
+              </a:lnSpc>
+              <a:spcAft>
+                <a:spcPts val="500"/>
+              </a:spcAft>
+              <a:buSzPct val="100000"/>
+              <a:buChar char="•"/>
+            </a:pPr>
+            <a:r>
+              <a:rPr lang="en-US" sz="820" dirty="0">
+                <a:solidFill>
+                  <a:srgbClr val="000000"/>
+                </a:solidFill>
+                <a:latin typeface="Arial" pitchFamily="34" charset="0"/>
+                <a:ea typeface="Arial" pitchFamily="34" charset="-122"/>
+                <a:cs typeface="Arial" pitchFamily="34" charset="-120"/>
+              </a:rPr>
+              <a:t>Observe peer leadership behaviour in context.</a:t>
+            </a:r>
+            <a:endParaRPr lang="en-US" sz="820" dirty="0"/>
+          </a:p>
+        </p:txBody>
+      </p:sp>
+      <p:sp>
+        <p:nvSpPr>
+          <p:cNvPr id="32" name="Shape 29"/>
+          <p:cNvSpPr/>
+          <p:nvPr/>
+        </p:nvSpPr>
+        <p:spPr>
+          <a:xfrm>
+            <a:off x="4974336" y="4187952"/>
+            <a:ext cx="2130552" cy="256032"/>
+          </a:xfrm>
+          <a:prstGeom prst="rect">
+            <a:avLst/>
+          </a:prstGeom>
+          <a:solidFill>
+            <a:srgbClr val="A89662"/>
+          </a:solidFill>
+          <a:ln/>
+        </p:spPr>
+      </p:sp>
+      <p:sp>
+        <p:nvSpPr>
+          <p:cNvPr id="33" name="Text 30"/>
+          <p:cNvSpPr/>
+          <p:nvPr/>
+        </p:nvSpPr>
+        <p:spPr>
+          <a:xfrm>
+            <a:off x="4974336" y="4187952"/>
+            <a:ext cx="2130552" cy="256032"/>
+          </a:xfrm>
+          <a:prstGeom prst="rect">
+            <a:avLst/>
+          </a:prstGeom>
+          <a:noFill/>
+          <a:ln/>
+        </p:spPr>
+        <p:txBody>
+          <a:bodyPr wrap="square" lIns="0" tIns="0" rIns="0" bIns="0" rtlCol="0" anchor="ctr"/>
+          <a:lstStyle/>
+          <a:p>
+            <a:pPr algn="ctr" indent="0" marL="0">
+              <a:buNone/>
+            </a:pPr>
+            <a:r>
+              <a:rPr lang="en-US" sz="950" b="1" spc="160" kern="0" dirty="0">
+                <a:solidFill>
+                  <a:srgbClr val="FFFFFF"/>
+                </a:solidFill>
+                <a:latin typeface="Arial" pitchFamily="34" charset="0"/>
+                <a:ea typeface="Arial" pitchFamily="34" charset="-122"/>
+                <a:cs typeface="Arial" pitchFamily="34" charset="-120"/>
+              </a:rPr>
+              <a:t>RECOVER</a:t>
+            </a:r>
+            <a:endParaRPr lang="en-US" sz="950" dirty="0"/>
+          </a:p>
+        </p:txBody>
+      </p:sp>
+      <p:sp>
+        <p:nvSpPr>
+          <p:cNvPr id="34" name="Text 31"/>
+          <p:cNvSpPr/>
+          <p:nvPr/>
+        </p:nvSpPr>
+        <p:spPr>
+          <a:xfrm>
+            <a:off x="4992624" y="4517136"/>
+            <a:ext cx="2093976" cy="969264"/>
+          </a:xfrm>
+          <a:prstGeom prst="rect">
+            <a:avLst/>
+          </a:prstGeom>
+          <a:noFill/>
+          <a:ln/>
+        </p:spPr>
+        <p:txBody>
+          <a:bodyPr wrap="square" lIns="0" tIns="0" rIns="0" bIns="0" rtlCol="0" anchor="t"/>
+          <a:lstStyle/>
+          <a:p>
+            <a:pPr algn="l" marL="127000" indent="-127000">
+              <a:lnSpc>
+                <a:spcPct val="110000"/>
+              </a:lnSpc>
+              <a:spcAft>
+                <a:spcPts val="500"/>
+              </a:spcAft>
+              <a:buSzPct val="100000"/>
+              <a:buChar char="•"/>
+            </a:pPr>
+            <a:r>
+              <a:rPr lang="en-US" sz="820" dirty="0">
+                <a:solidFill>
+                  <a:srgbClr val="000000"/>
+                </a:solidFill>
+                <a:latin typeface="Arial" pitchFamily="34" charset="0"/>
+                <a:ea typeface="Arial" pitchFamily="34" charset="-122"/>
+                <a:cs typeface="Arial" pitchFamily="34" charset="-120"/>
+              </a:rPr>
+              <a:t>Give and receive structured face-to-face feedback.</a:t>
+            </a:r>
+            <a:endParaRPr lang="en-US" sz="820" dirty="0"/>
+          </a:p>
+          <a:p>
+            <a:pPr algn="l" marL="127000" indent="-127000">
+              <a:lnSpc>
+                <a:spcPct val="110000"/>
+              </a:lnSpc>
+              <a:spcAft>
+                <a:spcPts val="500"/>
+              </a:spcAft>
+              <a:buSzPct val="100000"/>
+              <a:buChar char="•"/>
+            </a:pPr>
+            <a:r>
+              <a:rPr lang="en-US" sz="820" dirty="0">
+                <a:solidFill>
+                  <a:srgbClr val="000000"/>
+                </a:solidFill>
+                <a:latin typeface="Arial" pitchFamily="34" charset="0"/>
+                <a:ea typeface="Arial" pitchFamily="34" charset="-122"/>
+                <a:cs typeface="Arial" pitchFamily="34" charset="-120"/>
+              </a:rPr>
+              <a:t>Reflect on critical moments during the activity.</a:t>
+            </a:r>
+            <a:endParaRPr lang="en-US" sz="820" dirty="0"/>
+          </a:p>
+          <a:p>
+            <a:pPr algn="l" marL="127000" indent="-127000">
+              <a:lnSpc>
+                <a:spcPct val="110000"/>
+              </a:lnSpc>
+              <a:spcAft>
+                <a:spcPts val="500"/>
+              </a:spcAft>
+              <a:buSzPct val="100000"/>
+              <a:buChar char="•"/>
+            </a:pPr>
+            <a:r>
+              <a:rPr lang="en-US" sz="820" dirty="0">
+                <a:solidFill>
+                  <a:srgbClr val="000000"/>
+                </a:solidFill>
+                <a:latin typeface="Arial" pitchFamily="34" charset="0"/>
+                <a:ea typeface="Arial" pitchFamily="34" charset="-122"/>
+                <a:cs typeface="Arial" pitchFamily="34" charset="-120"/>
+              </a:rPr>
+              <a:t>Build a Leadership Development Plan and keep, stop, start Game Plan.</a:t>
+            </a:r>
+            <a:endParaRPr lang="en-US" sz="820" dirty="0"/>
+          </a:p>
+        </p:txBody>
+      </p:sp>
+      <p:sp>
+        <p:nvSpPr>
+          <p:cNvPr id="35" name="Text 32"/>
+          <p:cNvSpPr/>
+          <p:nvPr/>
+        </p:nvSpPr>
+        <p:spPr>
+          <a:xfrm>
+            <a:off x="457200" y="5760720"/>
+            <a:ext cx="6647688" cy="182880"/>
+          </a:xfrm>
+          <a:prstGeom prst="rect">
+            <a:avLst/>
+          </a:prstGeom>
+          <a:noFill/>
+          <a:ln/>
+        </p:spPr>
+        <p:txBody>
+          <a:bodyPr wrap="square" lIns="0" tIns="0" rIns="0" bIns="0" rtlCol="0" anchor="ctr"/>
+          <a:lstStyle/>
+          <a:p>
+            <a:pPr algn="l" indent="0" marL="0">
+              <a:buNone/>
+            </a:pPr>
+            <a:r>
+              <a:rPr lang="en-US" sz="850" b="1" spc="140" kern="0" dirty="0">
+                <a:solidFill>
+                  <a:srgbClr val="002516"/>
+                </a:solidFill>
+                <a:latin typeface="Arial" pitchFamily="34" charset="0"/>
+                <a:ea typeface="Arial" pitchFamily="34" charset="-122"/>
+                <a:cs typeface="Arial" pitchFamily="34" charset="-120"/>
+              </a:rPr>
+              <a:t>WHAT IS COVERED</a:t>
+            </a:r>
+            <a:endParaRPr lang="en-US" sz="850" dirty="0"/>
+          </a:p>
+        </p:txBody>
+      </p:sp>
+      <p:sp>
+        <p:nvSpPr>
+          <p:cNvPr id="36" name="Shape 33"/>
+          <p:cNvSpPr/>
+          <p:nvPr/>
+        </p:nvSpPr>
+        <p:spPr>
+          <a:xfrm>
+            <a:off x="457200" y="6035040"/>
+            <a:ext cx="41148" cy="128016"/>
+          </a:xfrm>
+          <a:prstGeom prst="rect">
+            <a:avLst/>
+          </a:prstGeom>
+          <a:solidFill>
+            <a:srgbClr val="C62026"/>
+          </a:solidFill>
+          <a:ln/>
+        </p:spPr>
+      </p:sp>
+      <p:sp>
+        <p:nvSpPr>
+          <p:cNvPr id="37" name="Text 34"/>
+          <p:cNvSpPr/>
+          <p:nvPr/>
+        </p:nvSpPr>
+        <p:spPr>
+          <a:xfrm>
+            <a:off x="585216" y="5998464"/>
+            <a:ext cx="1874520" cy="201168"/>
+          </a:xfrm>
+          <a:prstGeom prst="rect">
+            <a:avLst/>
+          </a:prstGeom>
+          <a:noFill/>
+          <a:ln/>
+        </p:spPr>
+        <p:txBody>
+          <a:bodyPr wrap="square" lIns="0" tIns="0" rIns="0" bIns="0" rtlCol="0" anchor="t"/>
+          <a:lstStyle/>
+          <a:p>
+            <a:pPr algn="l" indent="0" marL="0">
+              <a:buNone/>
+            </a:pPr>
+            <a:r>
+              <a:rPr lang="en-US" sz="880" b="1" dirty="0">
+                <a:solidFill>
+                  <a:srgbClr val="002516"/>
+                </a:solidFill>
+                <a:latin typeface="Arial" pitchFamily="34" charset="0"/>
+                <a:ea typeface="Arial" pitchFamily="34" charset="-122"/>
+                <a:cs typeface="Arial" pitchFamily="34" charset="-120"/>
+              </a:rPr>
+              <a:t>Leadership fundamentals</a:t>
+            </a:r>
+            <a:endParaRPr lang="en-US" sz="880" dirty="0"/>
+          </a:p>
+        </p:txBody>
+      </p:sp>
+      <p:sp>
+        <p:nvSpPr>
+          <p:cNvPr id="38" name="Text 35"/>
+          <p:cNvSpPr/>
+          <p:nvPr/>
+        </p:nvSpPr>
+        <p:spPr>
+          <a:xfrm>
+            <a:off x="2505456" y="5998464"/>
+            <a:ext cx="4599432" cy="384048"/>
           </a:xfrm>
           <a:prstGeom prst="rect">
             <a:avLst/>
@@ -1822,7 +2269,7 @@
                 <a:ea typeface="Arial" pitchFamily="34" charset="-122"/>
                 <a:cs typeface="Arial" pitchFamily="34" charset="-120"/>
               </a:rPr>
-              <a:t>Transfer observed behaviour into command effectiveness.</a:t>
+              <a:t>Command, management and leadership; the four pillars of trust; identity against reputation; and the four competency domains.</a:t>
             </a:r>
             <a:endParaRPr lang="en-US" sz="840" dirty="0"/>
           </a:p>
@@ -1830,30 +2277,50 @@
       </p:sp>
       <p:sp>
         <p:nvSpPr>
-          <p:cNvPr id="30" name="Text 27"/>
-          <p:cNvSpPr/>
-          <p:nvPr/>
-        </p:nvSpPr>
-        <p:spPr>
-          <a:xfrm>
-            <a:off x="457200" y="4663440"/>
-            <a:ext cx="6647688" cy="182880"/>
-          </a:xfrm>
-          <a:prstGeom prst="rect">
-            <a:avLst/>
-          </a:prstGeom>
-          <a:noFill/>
-          <a:ln/>
-        </p:spPr>
-        <p:txBody>
-          <a:bodyPr wrap="square" lIns="0" tIns="0" rIns="0" bIns="0" rtlCol="0" anchor="ctr"/>
+          <p:cNvPr id="39" name="Shape 36"/>
+          <p:cNvSpPr/>
+          <p:nvPr/>
+        </p:nvSpPr>
+        <p:spPr>
+          <a:xfrm>
+            <a:off x="457200" y="6455664"/>
+            <a:ext cx="41148" cy="128016"/>
+          </a:xfrm>
+          <a:prstGeom prst="rect">
+            <a:avLst/>
+          </a:prstGeom>
+          <a:solidFill>
+            <a:srgbClr val="C62026"/>
+          </a:solidFill>
+          <a:ln/>
+        </p:spPr>
+      </p:sp>
+      <p:sp>
+        <p:nvSpPr>
+          <p:cNvPr id="40" name="Text 37"/>
+          <p:cNvSpPr/>
+          <p:nvPr/>
+        </p:nvSpPr>
+        <p:spPr>
+          <a:xfrm>
+            <a:off x="585216" y="6419088"/>
+            <a:ext cx="1874520" cy="201168"/>
+          </a:xfrm>
+          <a:prstGeom prst="rect">
+            <a:avLst/>
+          </a:prstGeom>
+          <a:noFill/>
+          <a:ln/>
+        </p:spPr>
+        <p:txBody>
+          <a:bodyPr wrap="square" lIns="0" tIns="0" rIns="0" bIns="0" rtlCol="0" anchor="t"/>
           <a:lstStyle/>
           <a:p>
             <a:pPr algn="l" indent="0" marL="0">
               <a:buNone/>
             </a:pPr>
             <a:r>
-              <a:rPr lang="en-US" sz="850" b="1" spc="140" kern="0" dirty="0">
+              <a:rPr lang="en-US" sz="880" b="1" dirty="0">
                 <a:solidFill>
                   <a:srgbClr val="002516"/>
                 </a:solidFill>
@@ -1861,564 +2328,7 @@
                 <a:ea typeface="Arial" pitchFamily="34" charset="-122"/>
                 <a:cs typeface="Arial" pitchFamily="34" charset="-120"/>
               </a:rPr>
-              <a:t>HOW IT IS STRUCTURED: THE PERFORMANCE CYCLE</a:t>
-            </a:r>
-            <a:endParaRPr lang="en-US" sz="850" dirty="0"/>
-          </a:p>
-        </p:txBody>
-      </p:sp>
-      <p:sp>
-        <p:nvSpPr>
-          <p:cNvPr id="31" name="Shape 28"/>
-          <p:cNvSpPr/>
-          <p:nvPr/>
-        </p:nvSpPr>
-        <p:spPr>
-          <a:xfrm>
-            <a:off x="457200" y="4864608"/>
-            <a:ext cx="2130552" cy="237744"/>
-          </a:xfrm>
-          <a:prstGeom prst="rect">
-            <a:avLst/>
-          </a:prstGeom>
-          <a:solidFill>
-            <a:srgbClr val="002516"/>
-          </a:solidFill>
-          <a:ln/>
-        </p:spPr>
-      </p:sp>
-      <p:sp>
-        <p:nvSpPr>
-          <p:cNvPr id="32" name="Text 29"/>
-          <p:cNvSpPr/>
-          <p:nvPr/>
-        </p:nvSpPr>
-        <p:spPr>
-          <a:xfrm>
-            <a:off x="457200" y="4864608"/>
-            <a:ext cx="2130552" cy="237744"/>
-          </a:xfrm>
-          <a:prstGeom prst="rect">
-            <a:avLst/>
-          </a:prstGeom>
-          <a:noFill/>
-          <a:ln/>
-        </p:spPr>
-        <p:txBody>
-          <a:bodyPr wrap="square" lIns="0" tIns="0" rIns="0" bIns="0" rtlCol="0" anchor="ctr"/>
-          <a:lstStyle/>
-          <a:p>
-            <a:pPr algn="ctr" indent="0" marL="0">
-              <a:buNone/>
-            </a:pPr>
-            <a:r>
-              <a:rPr lang="en-US" sz="950" b="1" spc="160" kern="0" dirty="0">
-                <a:solidFill>
-                  <a:srgbClr val="FFFFFF"/>
-                </a:solidFill>
-                <a:latin typeface="Arial" pitchFamily="34" charset="0"/>
-                <a:ea typeface="Arial" pitchFamily="34" charset="-122"/>
-                <a:cs typeface="Arial" pitchFamily="34" charset="-120"/>
-              </a:rPr>
-              <a:t>PREPARE</a:t>
-            </a:r>
-            <a:endParaRPr lang="en-US" sz="950" dirty="0"/>
-          </a:p>
-        </p:txBody>
-      </p:sp>
-      <p:sp>
-        <p:nvSpPr>
-          <p:cNvPr id="33" name="Text 30"/>
-          <p:cNvSpPr/>
-          <p:nvPr/>
-        </p:nvSpPr>
-        <p:spPr>
-          <a:xfrm>
-            <a:off x="475488" y="5148072"/>
-            <a:ext cx="2093976" cy="1115568"/>
-          </a:xfrm>
-          <a:prstGeom prst="rect">
-            <a:avLst/>
-          </a:prstGeom>
-          <a:noFill/>
-          <a:ln/>
-        </p:spPr>
-        <p:txBody>
-          <a:bodyPr wrap="square" lIns="0" tIns="0" rIns="0" bIns="0" rtlCol="0" anchor="t"/>
-          <a:lstStyle/>
-          <a:p>
-            <a:pPr algn="l" marL="127000" indent="-127000">
-              <a:lnSpc>
-                <a:spcPct val="110000"/>
-              </a:lnSpc>
-              <a:spcAft>
-                <a:spcPts val="400"/>
-              </a:spcAft>
-              <a:buSzPct val="100000"/>
-              <a:buChar char="•"/>
-            </a:pPr>
-            <a:r>
-              <a:rPr lang="en-US" sz="820" dirty="0">
-                <a:solidFill>
-                  <a:srgbClr val="000000"/>
-                </a:solidFill>
-                <a:latin typeface="Arial" pitchFamily="34" charset="0"/>
-                <a:ea typeface="Arial" pitchFamily="34" charset="-122"/>
-                <a:cs typeface="Arial" pitchFamily="34" charset="-120"/>
-              </a:rPr>
-              <a:t>Leadership Personality Report: a Five Factor profile of behaviour day to day, under pressure, and the drivers behind it.</a:t>
-            </a:r>
-            <a:endParaRPr lang="en-US" sz="820" dirty="0"/>
-          </a:p>
-          <a:p>
-            <a:pPr algn="l" marL="127000" indent="-127000">
-              <a:lnSpc>
-                <a:spcPct val="110000"/>
-              </a:lnSpc>
-              <a:spcAft>
-                <a:spcPts val="400"/>
-              </a:spcAft>
-              <a:buSzPct val="100000"/>
-              <a:buChar char="•"/>
-            </a:pPr>
-            <a:r>
-              <a:rPr lang="en-US" sz="820" dirty="0">
-                <a:solidFill>
-                  <a:srgbClr val="000000"/>
-                </a:solidFill>
-                <a:latin typeface="Arial" pitchFamily="34" charset="0"/>
-                <a:ea typeface="Arial" pitchFamily="34" charset="-122"/>
-                <a:cs typeface="Arial" pitchFamily="34" charset="-120"/>
-              </a:rPr>
-              <a:t>Identify the behaviours that will help and hinder performance.</a:t>
-            </a:r>
-            <a:endParaRPr lang="en-US" sz="820" dirty="0"/>
-          </a:p>
-          <a:p>
-            <a:pPr algn="l" marL="127000" indent="-127000">
-              <a:lnSpc>
-                <a:spcPct val="110000"/>
-              </a:lnSpc>
-              <a:spcAft>
-                <a:spcPts val="400"/>
-              </a:spcAft>
-              <a:buSzPct val="100000"/>
-              <a:buChar char="•"/>
-            </a:pPr>
-            <a:r>
-              <a:rPr lang="en-US" sz="820" dirty="0">
-                <a:solidFill>
-                  <a:srgbClr val="000000"/>
-                </a:solidFill>
-                <a:latin typeface="Arial" pitchFamily="34" charset="0"/>
-                <a:ea typeface="Arial" pitchFamily="34" charset="-122"/>
-                <a:cs typeface="Arial" pitchFamily="34" charset="-120"/>
-              </a:rPr>
-              <a:t>Select the mental skills to be used during the activity.</a:t>
-            </a:r>
-            <a:endParaRPr lang="en-US" sz="820" dirty="0"/>
-          </a:p>
-        </p:txBody>
-      </p:sp>
-      <p:sp>
-        <p:nvSpPr>
-          <p:cNvPr id="34" name="Shape 31"/>
-          <p:cNvSpPr/>
-          <p:nvPr/>
-        </p:nvSpPr>
-        <p:spPr>
-          <a:xfrm>
-            <a:off x="2715768" y="4864608"/>
-            <a:ext cx="2130552" cy="237744"/>
-          </a:xfrm>
-          <a:prstGeom prst="rect">
-            <a:avLst/>
-          </a:prstGeom>
-          <a:solidFill>
-            <a:srgbClr val="3A4B00"/>
-          </a:solidFill>
-          <a:ln/>
-        </p:spPr>
-      </p:sp>
-      <p:sp>
-        <p:nvSpPr>
-          <p:cNvPr id="35" name="Text 32"/>
-          <p:cNvSpPr/>
-          <p:nvPr/>
-        </p:nvSpPr>
-        <p:spPr>
-          <a:xfrm>
-            <a:off x="2715768" y="4864608"/>
-            <a:ext cx="2130552" cy="237744"/>
-          </a:xfrm>
-          <a:prstGeom prst="rect">
-            <a:avLst/>
-          </a:prstGeom>
-          <a:noFill/>
-          <a:ln/>
-        </p:spPr>
-        <p:txBody>
-          <a:bodyPr wrap="square" lIns="0" tIns="0" rIns="0" bIns="0" rtlCol="0" anchor="ctr"/>
-          <a:lstStyle/>
-          <a:p>
-            <a:pPr algn="ctr" indent="0" marL="0">
-              <a:buNone/>
-            </a:pPr>
-            <a:r>
-              <a:rPr lang="en-US" sz="950" b="1" spc="160" kern="0" dirty="0">
-                <a:solidFill>
-                  <a:srgbClr val="FFFFFF"/>
-                </a:solidFill>
-                <a:latin typeface="Arial" pitchFamily="34" charset="0"/>
-                <a:ea typeface="Arial" pitchFamily="34" charset="-122"/>
-                <a:cs typeface="Arial" pitchFamily="34" charset="-120"/>
-              </a:rPr>
-              <a:t>PERFORM</a:t>
-            </a:r>
-            <a:endParaRPr lang="en-US" sz="950" dirty="0"/>
-          </a:p>
-        </p:txBody>
-      </p:sp>
-      <p:sp>
-        <p:nvSpPr>
-          <p:cNvPr id="36" name="Text 33"/>
-          <p:cNvSpPr/>
-          <p:nvPr/>
-        </p:nvSpPr>
-        <p:spPr>
-          <a:xfrm>
-            <a:off x="2734056" y="5148072"/>
-            <a:ext cx="2093976" cy="1115568"/>
-          </a:xfrm>
-          <a:prstGeom prst="rect">
-            <a:avLst/>
-          </a:prstGeom>
-          <a:noFill/>
-          <a:ln/>
-        </p:spPr>
-        <p:txBody>
-          <a:bodyPr wrap="square" lIns="0" tIns="0" rIns="0" bIns="0" rtlCol="0" anchor="t"/>
-          <a:lstStyle/>
-          <a:p>
-            <a:pPr algn="l" marL="127000" indent="-127000">
-              <a:lnSpc>
-                <a:spcPct val="110000"/>
-              </a:lnSpc>
-              <a:spcAft>
-                <a:spcPts val="400"/>
-              </a:spcAft>
-              <a:buSzPct val="100000"/>
-              <a:buChar char="•"/>
-            </a:pPr>
-            <a:r>
-              <a:rPr lang="en-US" sz="820" dirty="0">
-                <a:solidFill>
-                  <a:srgbClr val="000000"/>
-                </a:solidFill>
-                <a:latin typeface="Arial" pitchFamily="34" charset="0"/>
-                <a:ea typeface="Arial" pitchFamily="34" charset="-122"/>
-                <a:cs typeface="Arial" pitchFamily="34" charset="-120"/>
-              </a:rPr>
-              <a:t>Execute the activity as a team under sustained physical and mental load.</a:t>
-            </a:r>
-            <a:endParaRPr lang="en-US" sz="820" dirty="0"/>
-          </a:p>
-          <a:p>
-            <a:pPr algn="l" marL="127000" indent="-127000">
-              <a:lnSpc>
-                <a:spcPct val="110000"/>
-              </a:lnSpc>
-              <a:spcAft>
-                <a:spcPts val="400"/>
-              </a:spcAft>
-              <a:buSzPct val="100000"/>
-              <a:buChar char="•"/>
-            </a:pPr>
-            <a:r>
-              <a:rPr lang="en-US" sz="820" dirty="0">
-                <a:solidFill>
-                  <a:srgbClr val="000000"/>
-                </a:solidFill>
-                <a:latin typeface="Arial" pitchFamily="34" charset="0"/>
-                <a:ea typeface="Arial" pitchFamily="34" charset="-122"/>
-                <a:cs typeface="Arial" pitchFamily="34" charset="-120"/>
-              </a:rPr>
-              <a:t>Apply the selected behaviours and mental skills in real time.</a:t>
-            </a:r>
-            <a:endParaRPr lang="en-US" sz="820" dirty="0"/>
-          </a:p>
-          <a:p>
-            <a:pPr algn="l" marL="127000" indent="-127000">
-              <a:lnSpc>
-                <a:spcPct val="110000"/>
-              </a:lnSpc>
-              <a:spcAft>
-                <a:spcPts val="400"/>
-              </a:spcAft>
-              <a:buSzPct val="100000"/>
-              <a:buChar char="•"/>
-            </a:pPr>
-            <a:r>
-              <a:rPr lang="en-US" sz="820" dirty="0">
-                <a:solidFill>
-                  <a:srgbClr val="000000"/>
-                </a:solidFill>
-                <a:latin typeface="Arial" pitchFamily="34" charset="0"/>
-                <a:ea typeface="Arial" pitchFamily="34" charset="-122"/>
-                <a:cs typeface="Arial" pitchFamily="34" charset="-120"/>
-              </a:rPr>
-              <a:t>Peers observe leadership behaviour continuously, in context.</a:t>
-            </a:r>
-            <a:endParaRPr lang="en-US" sz="820" dirty="0"/>
-          </a:p>
-        </p:txBody>
-      </p:sp>
-      <p:sp>
-        <p:nvSpPr>
-          <p:cNvPr id="37" name="Shape 34"/>
-          <p:cNvSpPr/>
-          <p:nvPr/>
-        </p:nvSpPr>
-        <p:spPr>
-          <a:xfrm>
-            <a:off x="4974336" y="4864608"/>
-            <a:ext cx="2130552" cy="237744"/>
-          </a:xfrm>
-          <a:prstGeom prst="rect">
-            <a:avLst/>
-          </a:prstGeom>
-          <a:solidFill>
-            <a:srgbClr val="A89662"/>
-          </a:solidFill>
-          <a:ln/>
-        </p:spPr>
-      </p:sp>
-      <p:sp>
-        <p:nvSpPr>
-          <p:cNvPr id="38" name="Text 35"/>
-          <p:cNvSpPr/>
-          <p:nvPr/>
-        </p:nvSpPr>
-        <p:spPr>
-          <a:xfrm>
-            <a:off x="4974336" y="4864608"/>
-            <a:ext cx="2130552" cy="237744"/>
-          </a:xfrm>
-          <a:prstGeom prst="rect">
-            <a:avLst/>
-          </a:prstGeom>
-          <a:noFill/>
-          <a:ln/>
-        </p:spPr>
-        <p:txBody>
-          <a:bodyPr wrap="square" lIns="0" tIns="0" rIns="0" bIns="0" rtlCol="0" anchor="ctr"/>
-          <a:lstStyle/>
-          <a:p>
-            <a:pPr algn="ctr" indent="0" marL="0">
-              <a:buNone/>
-            </a:pPr>
-            <a:r>
-              <a:rPr lang="en-US" sz="950" b="1" spc="160" kern="0" dirty="0">
-                <a:solidFill>
-                  <a:srgbClr val="FFFFFF"/>
-                </a:solidFill>
-                <a:latin typeface="Arial" pitchFamily="34" charset="0"/>
-                <a:ea typeface="Arial" pitchFamily="34" charset="-122"/>
-                <a:cs typeface="Arial" pitchFamily="34" charset="-120"/>
-              </a:rPr>
-              <a:t>RECOVER</a:t>
-            </a:r>
-            <a:endParaRPr lang="en-US" sz="950" dirty="0"/>
-          </a:p>
-        </p:txBody>
-      </p:sp>
-      <p:sp>
-        <p:nvSpPr>
-          <p:cNvPr id="39" name="Text 36"/>
-          <p:cNvSpPr/>
-          <p:nvPr/>
-        </p:nvSpPr>
-        <p:spPr>
-          <a:xfrm>
-            <a:off x="4992624" y="5148072"/>
-            <a:ext cx="2093976" cy="1115568"/>
-          </a:xfrm>
-          <a:prstGeom prst="rect">
-            <a:avLst/>
-          </a:prstGeom>
-          <a:noFill/>
-          <a:ln/>
-        </p:spPr>
-        <p:txBody>
-          <a:bodyPr wrap="square" lIns="0" tIns="0" rIns="0" bIns="0" rtlCol="0" anchor="t"/>
-          <a:lstStyle/>
-          <a:p>
-            <a:pPr algn="l" marL="127000" indent="-127000">
-              <a:lnSpc>
-                <a:spcPct val="110000"/>
-              </a:lnSpc>
-              <a:spcAft>
-                <a:spcPts val="400"/>
-              </a:spcAft>
-              <a:buSzPct val="100000"/>
-              <a:buChar char="•"/>
-            </a:pPr>
-            <a:r>
-              <a:rPr lang="en-US" sz="820" dirty="0">
-                <a:solidFill>
-                  <a:srgbClr val="000000"/>
-                </a:solidFill>
-                <a:latin typeface="Arial" pitchFamily="34" charset="0"/>
-                <a:ea typeface="Arial" pitchFamily="34" charset="-122"/>
-                <a:cs typeface="Arial" pitchFamily="34" charset="-120"/>
-              </a:rPr>
-              <a:t>Structured self and peer feedback, written then delivered face to face.</a:t>
-            </a:r>
-            <a:endParaRPr lang="en-US" sz="820" dirty="0"/>
-          </a:p>
-          <a:p>
-            <a:pPr algn="l" marL="127000" indent="-127000">
-              <a:lnSpc>
-                <a:spcPct val="110000"/>
-              </a:lnSpc>
-              <a:spcAft>
-                <a:spcPts val="400"/>
-              </a:spcAft>
-              <a:buSzPct val="100000"/>
-              <a:buChar char="•"/>
-            </a:pPr>
-            <a:r>
-              <a:rPr lang="en-US" sz="820" dirty="0">
-                <a:solidFill>
-                  <a:srgbClr val="000000"/>
-                </a:solidFill>
-                <a:latin typeface="Arial" pitchFamily="34" charset="0"/>
-                <a:ea typeface="Arial" pitchFamily="34" charset="-122"/>
-                <a:cs typeface="Arial" pitchFamily="34" charset="-120"/>
-              </a:rPr>
-              <a:t>Systematic self-reflection on the hardest moments of the activity.</a:t>
-            </a:r>
-            <a:endParaRPr lang="en-US" sz="820" dirty="0"/>
-          </a:p>
-          <a:p>
-            <a:pPr algn="l" marL="127000" indent="-127000">
-              <a:lnSpc>
-                <a:spcPct val="110000"/>
-              </a:lnSpc>
-              <a:spcAft>
-                <a:spcPts val="400"/>
-              </a:spcAft>
-              <a:buSzPct val="100000"/>
-              <a:buChar char="•"/>
-            </a:pPr>
-            <a:r>
-              <a:rPr lang="en-US" sz="820" dirty="0">
-                <a:solidFill>
-                  <a:srgbClr val="000000"/>
-                </a:solidFill>
-                <a:latin typeface="Arial" pitchFamily="34" charset="0"/>
-                <a:ea typeface="Arial" pitchFamily="34" charset="-122"/>
-                <a:cs typeface="Arial" pitchFamily="34" charset="-120"/>
-              </a:rPr>
-              <a:t>Build the Leadership Development Plan and keep, stop, start Game Plan.</a:t>
-            </a:r>
-            <a:endParaRPr lang="en-US" sz="820" dirty="0"/>
-          </a:p>
-        </p:txBody>
-      </p:sp>
-      <p:sp>
-        <p:nvSpPr>
-          <p:cNvPr id="40" name="Text 37"/>
-          <p:cNvSpPr/>
-          <p:nvPr/>
-        </p:nvSpPr>
-        <p:spPr>
-          <a:xfrm>
-            <a:off x="457200" y="6400800"/>
-            <a:ext cx="6647688" cy="182880"/>
-          </a:xfrm>
-          <a:prstGeom prst="rect">
-            <a:avLst/>
-          </a:prstGeom>
-          <a:noFill/>
-          <a:ln/>
-        </p:spPr>
-        <p:txBody>
-          <a:bodyPr wrap="square" lIns="0" tIns="0" rIns="0" bIns="0" rtlCol="0" anchor="ctr"/>
-          <a:lstStyle/>
-          <a:p>
-            <a:pPr algn="l" indent="0" marL="0">
-              <a:buNone/>
-            </a:pPr>
-            <a:r>
-              <a:rPr lang="en-US" sz="850" b="1" spc="140" kern="0" dirty="0">
-                <a:solidFill>
-                  <a:srgbClr val="002516"/>
-                </a:solidFill>
-                <a:latin typeface="Arial" pitchFamily="34" charset="0"/>
-                <a:ea typeface="Arial" pitchFamily="34" charset="-122"/>
-                <a:cs typeface="Arial" pitchFamily="34" charset="-120"/>
-              </a:rPr>
-              <a:t>WHAT IS COVERED</a:t>
-            </a:r>
-            <a:endParaRPr lang="en-US" sz="850" dirty="0"/>
-          </a:p>
-        </p:txBody>
-      </p:sp>
-      <p:sp>
-        <p:nvSpPr>
-          <p:cNvPr id="41" name="Shape 38"/>
-          <p:cNvSpPr/>
-          <p:nvPr/>
-        </p:nvSpPr>
-        <p:spPr>
-          <a:xfrm>
-            <a:off x="457200" y="6638544"/>
-            <a:ext cx="41148" cy="128016"/>
-          </a:xfrm>
-          <a:prstGeom prst="rect">
-            <a:avLst/>
-          </a:prstGeom>
-          <a:solidFill>
-            <a:srgbClr val="C62026"/>
-          </a:solidFill>
-          <a:ln/>
-        </p:spPr>
-      </p:sp>
-      <p:sp>
-        <p:nvSpPr>
-          <p:cNvPr id="42" name="Text 39"/>
-          <p:cNvSpPr/>
-          <p:nvPr/>
-        </p:nvSpPr>
-        <p:spPr>
-          <a:xfrm>
-            <a:off x="585216" y="6601968"/>
-            <a:ext cx="1874520" cy="201168"/>
-          </a:xfrm>
-          <a:prstGeom prst="rect">
-            <a:avLst/>
-          </a:prstGeom>
-          <a:noFill/>
-          <a:ln/>
-        </p:spPr>
-        <p:txBody>
-          <a:bodyPr wrap="square" lIns="0" tIns="0" rIns="0" bIns="0" rtlCol="0" anchor="t"/>
-          <a:lstStyle/>
-          <a:p>
-            <a:pPr algn="l" indent="0" marL="0">
-              <a:buNone/>
-            </a:pPr>
-            <a:r>
-              <a:rPr lang="en-US" sz="880" b="1" dirty="0">
-                <a:solidFill>
-                  <a:srgbClr val="002516"/>
-                </a:solidFill>
-                <a:latin typeface="Arial" pitchFamily="34" charset="0"/>
-                <a:ea typeface="Arial" pitchFamily="34" charset="-122"/>
-                <a:cs typeface="Arial" pitchFamily="34" charset="-120"/>
-              </a:rPr>
-              <a:t>Leadership fundamentals</a:t>
+              <a:t>Leadership Personality Report</a:t>
             </a:r>
             <a:endParaRPr lang="en-US" sz="880" dirty="0"/>
           </a:p>
@@ -2426,14 +2336,14 @@
       </p:sp>
       <p:sp>
         <p:nvSpPr>
-          <p:cNvPr id="43" name="Text 40"/>
-          <p:cNvSpPr/>
-          <p:nvPr/>
-        </p:nvSpPr>
-        <p:spPr>
-          <a:xfrm>
-            <a:off x="2505456" y="6601968"/>
-            <a:ext cx="4599432" cy="402336"/>
+          <p:cNvPr id="41" name="Text 38"/>
+          <p:cNvSpPr/>
+          <p:nvPr/>
+        </p:nvSpPr>
+        <p:spPr>
+          <a:xfrm>
+            <a:off x="2505456" y="6419088"/>
+            <a:ext cx="4599432" cy="384048"/>
           </a:xfrm>
           <a:prstGeom prst="rect">
             <a:avLst/>
@@ -2452,7 +2362,7 @@
               <a:buNone/>
             </a:pPr>
             <a:r>
-              <a:rPr lang="en-US" sz="820" dirty="0">
+              <a:rPr lang="en-US" sz="840" dirty="0">
                 <a:solidFill>
                   <a:srgbClr val="000000"/>
                 </a:solidFill>
@@ -2460,21 +2370,21 @@
                 <a:ea typeface="Arial" pitchFamily="34" charset="-122"/>
                 <a:cs typeface="Arial" pitchFamily="34" charset="-120"/>
               </a:rPr>
-              <a:t>Command, management and leadership as distinct functions. The four pillars of trust: competence, predictability, benevolence and integrity. Identity against reputation, and the four competency domains.</a:t>
-            </a:r>
-            <a:endParaRPr lang="en-US" sz="820" dirty="0"/>
-          </a:p>
-        </p:txBody>
-      </p:sp>
-      <p:sp>
-        <p:nvSpPr>
-          <p:cNvPr id="44" name="Shape 41"/>
-          <p:cNvSpPr/>
-          <p:nvPr/>
-        </p:nvSpPr>
-        <p:spPr>
-          <a:xfrm>
-            <a:off x="457200" y="7059168"/>
+              <a:t>A validated Five Factor profile of everyday behaviour, behaviour under pressure, and underlying needs and drivers.</a:t>
+            </a:r>
+            <a:endParaRPr lang="en-US" sz="840" dirty="0"/>
+          </a:p>
+        </p:txBody>
+      </p:sp>
+      <p:sp>
+        <p:nvSpPr>
+          <p:cNvPr id="42" name="Shape 39"/>
+          <p:cNvSpPr/>
+          <p:nvPr/>
+        </p:nvSpPr>
+        <p:spPr>
+          <a:xfrm>
+            <a:off x="457200" y="6876288"/>
             <a:ext cx="41148" cy="128016"/>
           </a:xfrm>
           <a:prstGeom prst="rect">
@@ -2488,13 +2398,13 @@
       </p:sp>
       <p:sp>
         <p:nvSpPr>
-          <p:cNvPr id="45" name="Text 42"/>
-          <p:cNvSpPr/>
-          <p:nvPr/>
-        </p:nvSpPr>
-        <p:spPr>
-          <a:xfrm>
-            <a:off x="585216" y="7022592"/>
+          <p:cNvPr id="43" name="Text 40"/>
+          <p:cNvSpPr/>
+          <p:nvPr/>
+        </p:nvSpPr>
+        <p:spPr>
+          <a:xfrm>
+            <a:off x="585216" y="6839712"/>
             <a:ext cx="1874520" cy="201168"/>
           </a:xfrm>
           <a:prstGeom prst="rect">
@@ -2519,7 +2429,7 @@
                 <a:ea typeface="Arial" pitchFamily="34" charset="-122"/>
                 <a:cs typeface="Arial" pitchFamily="34" charset="-120"/>
               </a:rPr>
-              <a:t>Leadership Personality Report</a:t>
+              <a:t>Self and peer feedback</a:t>
             </a:r>
             <a:endParaRPr lang="en-US" sz="880" dirty="0"/>
           </a:p>
@@ -2527,14 +2437,14 @@
       </p:sp>
       <p:sp>
         <p:nvSpPr>
-          <p:cNvPr id="46" name="Text 43"/>
-          <p:cNvSpPr/>
-          <p:nvPr/>
-        </p:nvSpPr>
-        <p:spPr>
-          <a:xfrm>
-            <a:off x="2505456" y="7022592"/>
-            <a:ext cx="4599432" cy="402336"/>
+          <p:cNvPr id="44" name="Text 41"/>
+          <p:cNvSpPr/>
+          <p:nvPr/>
+        </p:nvSpPr>
+        <p:spPr>
+          <a:xfrm>
+            <a:off x="2505456" y="6839712"/>
+            <a:ext cx="4599432" cy="384048"/>
           </a:xfrm>
           <a:prstGeom prst="rect">
             <a:avLst/>
@@ -2553,7 +2463,7 @@
               <a:buNone/>
             </a:pPr>
             <a:r>
-              <a:rPr lang="en-US" sz="820" dirty="0">
+              <a:rPr lang="en-US" sz="840" dirty="0">
                 <a:solidFill>
                   <a:srgbClr val="000000"/>
                 </a:solidFill>
@@ -2561,21 +2471,21 @@
                 <a:ea typeface="Arial" pitchFamily="34" charset="-122"/>
                 <a:cs typeface="Arial" pitchFamily="34" charset="-120"/>
               </a:rPr>
-              <a:t>A validated Five Factor instrument reporting day to day behaviour, behaviour under pressure or with the guard down, and the needs and drivers behind it.</a:t>
-            </a:r>
-            <a:endParaRPr lang="en-US" sz="820" dirty="0"/>
-          </a:p>
-        </p:txBody>
-      </p:sp>
-      <p:sp>
-        <p:nvSpPr>
-          <p:cNvPr id="47" name="Shape 44"/>
-          <p:cNvSpPr/>
-          <p:nvPr/>
-        </p:nvSpPr>
-        <p:spPr>
-          <a:xfrm>
-            <a:off x="457200" y="7479792"/>
+              <a:t>One strength to sustain and one behaviour to adapt, supported by evidence observed during the activity.</a:t>
+            </a:r>
+            <a:endParaRPr lang="en-US" sz="840" dirty="0"/>
+          </a:p>
+        </p:txBody>
+      </p:sp>
+      <p:sp>
+        <p:nvSpPr>
+          <p:cNvPr id="45" name="Shape 42"/>
+          <p:cNvSpPr/>
+          <p:nvPr/>
+        </p:nvSpPr>
+        <p:spPr>
+          <a:xfrm>
+            <a:off x="457200" y="7296912"/>
             <a:ext cx="41148" cy="128016"/>
           </a:xfrm>
           <a:prstGeom prst="rect">
@@ -2589,13 +2499,13 @@
       </p:sp>
       <p:sp>
         <p:nvSpPr>
-          <p:cNvPr id="48" name="Text 45"/>
-          <p:cNvSpPr/>
-          <p:nvPr/>
-        </p:nvSpPr>
-        <p:spPr>
-          <a:xfrm>
-            <a:off x="585216" y="7443216"/>
+          <p:cNvPr id="46" name="Text 43"/>
+          <p:cNvSpPr/>
+          <p:nvPr/>
+        </p:nvSpPr>
+        <p:spPr>
+          <a:xfrm>
+            <a:off x="585216" y="7260336"/>
             <a:ext cx="1874520" cy="201168"/>
           </a:xfrm>
           <a:prstGeom prst="rect">
@@ -2620,7 +2530,7 @@
                 <a:ea typeface="Arial" pitchFamily="34" charset="-122"/>
                 <a:cs typeface="Arial" pitchFamily="34" charset="-120"/>
               </a:rPr>
-              <a:t>Self and peer feedback</a:t>
+              <a:t>Performance under pressure</a:t>
             </a:r>
             <a:endParaRPr lang="en-US" sz="880" dirty="0"/>
           </a:p>
@@ -2628,14 +2538,14 @@
       </p:sp>
       <p:sp>
         <p:nvSpPr>
-          <p:cNvPr id="49" name="Text 46"/>
-          <p:cNvSpPr/>
-          <p:nvPr/>
-        </p:nvSpPr>
-        <p:spPr>
-          <a:xfrm>
-            <a:off x="2505456" y="7443216"/>
-            <a:ext cx="4599432" cy="402336"/>
+          <p:cNvPr id="47" name="Text 44"/>
+          <p:cNvSpPr/>
+          <p:nvPr/>
+        </p:nvSpPr>
+        <p:spPr>
+          <a:xfrm>
+            <a:off x="2505456" y="7260336"/>
+            <a:ext cx="4599432" cy="384048"/>
           </a:xfrm>
           <a:prstGeom prst="rect">
             <a:avLst/>
@@ -2654,7 +2564,7 @@
               <a:buNone/>
             </a:pPr>
             <a:r>
-              <a:rPr lang="en-US" sz="820" dirty="0">
+              <a:rPr lang="en-US" sz="840" dirty="0">
                 <a:solidFill>
                   <a:srgbClr val="000000"/>
                 </a:solidFill>
@@ -2662,21 +2572,21 @@
                 <a:ea typeface="Arial" pitchFamily="34" charset="-122"/>
                 <a:cs typeface="Arial" pitchFamily="34" charset="-120"/>
               </a:rPr>
-              <a:t>Every participant gives and receives specific behavioural feedback on one strength to sustain and one behaviour to adapt, evidenced by what was observed during the activity.</a:t>
-            </a:r>
-            <a:endParaRPr lang="en-US" sz="820" dirty="0"/>
-          </a:p>
-        </p:txBody>
-      </p:sp>
-      <p:sp>
-        <p:nvSpPr>
-          <p:cNvPr id="50" name="Shape 47"/>
-          <p:cNvSpPr/>
-          <p:nvPr/>
-        </p:nvSpPr>
-        <p:spPr>
-          <a:xfrm>
-            <a:off x="457200" y="7900416"/>
+              <a:t>Red head and blue head, performance as potential less interference, and practical mental skills including tactical breathing, self-talk, visualisation, chunking and recovery.</a:t>
+            </a:r>
+            <a:endParaRPr lang="en-US" sz="840" dirty="0"/>
+          </a:p>
+        </p:txBody>
+      </p:sp>
+      <p:sp>
+        <p:nvSpPr>
+          <p:cNvPr id="48" name="Shape 45"/>
+          <p:cNvSpPr/>
+          <p:nvPr/>
+        </p:nvSpPr>
+        <p:spPr>
+          <a:xfrm>
+            <a:off x="457200" y="7717536"/>
             <a:ext cx="41148" cy="128016"/>
           </a:xfrm>
           <a:prstGeom prst="rect">
@@ -2690,13 +2600,13 @@
       </p:sp>
       <p:sp>
         <p:nvSpPr>
-          <p:cNvPr id="51" name="Text 48"/>
-          <p:cNvSpPr/>
-          <p:nvPr/>
-        </p:nvSpPr>
-        <p:spPr>
-          <a:xfrm>
-            <a:off x="585216" y="7863840"/>
+          <p:cNvPr id="49" name="Text 46"/>
+          <p:cNvSpPr/>
+          <p:nvPr/>
+        </p:nvSpPr>
+        <p:spPr>
+          <a:xfrm>
+            <a:off x="585216" y="7680960"/>
             <a:ext cx="1874520" cy="201168"/>
           </a:xfrm>
           <a:prstGeom prst="rect">
@@ -2721,7 +2631,7 @@
                 <a:ea typeface="Arial" pitchFamily="34" charset="-122"/>
                 <a:cs typeface="Arial" pitchFamily="34" charset="-120"/>
               </a:rPr>
-              <a:t>Performance under pressure</a:t>
+              <a:t>Leadership Development Plan</a:t>
             </a:r>
             <a:endParaRPr lang="en-US" sz="880" dirty="0"/>
           </a:p>
@@ -2729,14 +2639,14 @@
       </p:sp>
       <p:sp>
         <p:nvSpPr>
-          <p:cNvPr id="52" name="Text 49"/>
-          <p:cNvSpPr/>
-          <p:nvPr/>
-        </p:nvSpPr>
-        <p:spPr>
-          <a:xfrm>
-            <a:off x="2505456" y="7863840"/>
-            <a:ext cx="4599432" cy="402336"/>
+          <p:cNvPr id="50" name="Text 47"/>
+          <p:cNvSpPr/>
+          <p:nvPr/>
+        </p:nvSpPr>
+        <p:spPr>
+          <a:xfrm>
+            <a:off x="2505456" y="7680960"/>
+            <a:ext cx="4599432" cy="384048"/>
           </a:xfrm>
           <a:prstGeom prst="rect">
             <a:avLst/>
@@ -2755,7 +2665,7 @@
               <a:buNone/>
             </a:pPr>
             <a:r>
-              <a:rPr lang="en-US" sz="820" dirty="0">
+              <a:rPr lang="en-US" sz="840" dirty="0">
                 <a:solidFill>
                   <a:srgbClr val="000000"/>
                 </a:solidFill>
@@ -2763,127 +2673,26 @@
                 <a:ea typeface="Arial" pitchFamily="34" charset="-122"/>
                 <a:cs typeface="Arial" pitchFamily="34" charset="-120"/>
               </a:rPr>
-              <a:t>Red head and blue head, performance as potential less interference, and a mental-skills set: noticing, grounding, tactical breathing, self-talk, visualisation, chunking and recovery habits.</a:t>
-            </a:r>
-            <a:endParaRPr lang="en-US" sz="820" dirty="0"/>
-          </a:p>
-        </p:txBody>
-      </p:sp>
-      <p:sp>
-        <p:nvSpPr>
-          <p:cNvPr id="53" name="Shape 50"/>
-          <p:cNvSpPr/>
-          <p:nvPr/>
-        </p:nvSpPr>
-        <p:spPr>
-          <a:xfrm>
-            <a:off x="457200" y="8321040"/>
-            <a:ext cx="41148" cy="128016"/>
-          </a:xfrm>
-          <a:prstGeom prst="rect">
-            <a:avLst/>
-          </a:prstGeom>
-          <a:solidFill>
-            <a:srgbClr val="C62026"/>
-          </a:solidFill>
-          <a:ln/>
-        </p:spPr>
-      </p:sp>
-      <p:sp>
-        <p:nvSpPr>
-          <p:cNvPr id="54" name="Text 51"/>
-          <p:cNvSpPr/>
-          <p:nvPr/>
-        </p:nvSpPr>
-        <p:spPr>
-          <a:xfrm>
-            <a:off x="585216" y="8284464"/>
-            <a:ext cx="1874520" cy="201168"/>
-          </a:xfrm>
-          <a:prstGeom prst="rect">
-            <a:avLst/>
-          </a:prstGeom>
-          <a:noFill/>
-          <a:ln/>
-        </p:spPr>
-        <p:txBody>
-          <a:bodyPr wrap="square" lIns="0" tIns="0" rIns="0" bIns="0" rtlCol="0" anchor="t"/>
-          <a:lstStyle/>
-          <a:p>
-            <a:pPr algn="l" indent="0" marL="0">
-              <a:buNone/>
-            </a:pPr>
-            <a:r>
-              <a:rPr lang="en-US" sz="880" b="1" dirty="0">
-                <a:solidFill>
-                  <a:srgbClr val="002516"/>
-                </a:solidFill>
-                <a:latin typeface="Arial" pitchFamily="34" charset="0"/>
-                <a:ea typeface="Arial" pitchFamily="34" charset="-122"/>
-                <a:cs typeface="Arial" pitchFamily="34" charset="-120"/>
-              </a:rPr>
-              <a:t>Leadership Development Plan</a:t>
-            </a:r>
-            <a:endParaRPr lang="en-US" sz="880" dirty="0"/>
-          </a:p>
-        </p:txBody>
-      </p:sp>
-      <p:sp>
-        <p:nvSpPr>
-          <p:cNvPr id="55" name="Text 52"/>
-          <p:cNvSpPr/>
-          <p:nvPr/>
-        </p:nvSpPr>
-        <p:spPr>
-          <a:xfrm>
-            <a:off x="2505456" y="8284464"/>
-            <a:ext cx="4599432" cy="402336"/>
-          </a:xfrm>
-          <a:prstGeom prst="rect">
-            <a:avLst/>
-          </a:prstGeom>
-          <a:noFill/>
-          <a:ln/>
-        </p:spPr>
-        <p:txBody>
-          <a:bodyPr wrap="square" lIns="0" tIns="0" rIns="0" bIns="0" rtlCol="0" anchor="t"/>
-          <a:lstStyle/>
-          <a:p>
-            <a:pPr algn="l" indent="0" marL="0">
-              <a:lnSpc>
-                <a:spcPct val="110000"/>
-              </a:lnSpc>
-              <a:buNone/>
-            </a:pPr>
-            <a:r>
-              <a:rPr lang="en-US" sz="820" dirty="0">
-                <a:solidFill>
-                  <a:srgbClr val="000000"/>
-                </a:solidFill>
-                <a:latin typeface="Arial" pitchFamily="34" charset="0"/>
-                <a:ea typeface="Arial" pitchFamily="34" charset="-122"/>
-                <a:cs typeface="Arial" pitchFamily="34" charset="-120"/>
-              </a:rPr>
-              <a:t>Three leadership behaviours to sustain and three to adapt, converted into keep, stop and start strategies that are effective, actionable and observable, then disclosed to the team.</a:t>
-            </a:r>
-            <a:endParaRPr lang="en-US" sz="820" dirty="0"/>
-          </a:p>
-        </p:txBody>
-      </p:sp>
-      <p:sp>
-        <p:nvSpPr>
-          <p:cNvPr id="56" name="Shape 53"/>
-          <p:cNvSpPr/>
-          <p:nvPr/>
-        </p:nvSpPr>
-        <p:spPr>
-          <a:xfrm>
-            <a:off x="457200" y="8741664"/>
-            <a:ext cx="6647688" cy="822960"/>
+              <a:t>Three behaviours to sustain and three to adapt, converted into observable keep, stop and start actions.</a:t>
+            </a:r>
+            <a:endParaRPr lang="en-US" sz="840" dirty="0"/>
+          </a:p>
+        </p:txBody>
+      </p:sp>
+      <p:sp>
+        <p:nvSpPr>
+          <p:cNvPr id="51" name="Shape 48"/>
+          <p:cNvSpPr/>
+          <p:nvPr/>
+        </p:nvSpPr>
+        <p:spPr>
+          <a:xfrm>
+            <a:off x="457200" y="8284464"/>
+            <a:ext cx="6647688" cy="804672"/>
           </a:xfrm>
           <a:prstGeom prst="roundRect">
             <a:avLst>
-              <a:gd name="adj" fmla="val 6667"/>
+              <a:gd name="adj" fmla="val 6818"/>
             </a:avLst>
           </a:prstGeom>
           <a:solidFill>
@@ -2896,13 +2705,13 @@
       </p:sp>
       <p:sp>
         <p:nvSpPr>
-          <p:cNvPr id="57" name="Text 54"/>
-          <p:cNvSpPr/>
-          <p:nvPr/>
-        </p:nvSpPr>
-        <p:spPr>
-          <a:xfrm>
-            <a:off x="658368" y="8805672"/>
+          <p:cNvPr id="52" name="Text 49"/>
+          <p:cNvSpPr/>
+          <p:nvPr/>
+        </p:nvSpPr>
+        <p:spPr>
+          <a:xfrm>
+            <a:off x="658368" y="8366760"/>
             <a:ext cx="6245352" cy="182880"/>
           </a:xfrm>
           <a:prstGeom prst="rect">
@@ -2935,14 +2744,14 @@
       </p:sp>
       <p:sp>
         <p:nvSpPr>
-          <p:cNvPr id="58" name="Text 55"/>
-          <p:cNvSpPr/>
-          <p:nvPr/>
-        </p:nvSpPr>
-        <p:spPr>
-          <a:xfrm>
-            <a:off x="658368" y="9006840"/>
-            <a:ext cx="3031236" cy="246888"/>
+          <p:cNvPr id="53" name="Text 50"/>
+          <p:cNvSpPr/>
+          <p:nvPr/>
+        </p:nvSpPr>
+        <p:spPr>
+          <a:xfrm>
+            <a:off x="658368" y="8577072"/>
+            <a:ext cx="3031236" cy="228600"/>
           </a:xfrm>
           <a:prstGeom prst="rect">
             <a:avLst/>
@@ -2959,7 +2768,7 @@
               <a:buChar char="•"/>
             </a:pPr>
             <a:r>
-              <a:rPr lang="en-US" sz="810" dirty="0">
+              <a:rPr lang="en-US" sz="840" dirty="0">
                 <a:solidFill>
                   <a:srgbClr val="000000"/>
                 </a:solidFill>
@@ -2967,22 +2776,22 @@
                 <a:ea typeface="Arial" pitchFamily="34" charset="-122"/>
                 <a:cs typeface="Arial" pitchFamily="34" charset="-120"/>
               </a:rPr>
-              <a:t>Leadership behaviour assessed under real load, not self-reported.</a:t>
-            </a:r>
-            <a:endParaRPr lang="en-US" sz="810" dirty="0"/>
-          </a:p>
-        </p:txBody>
-      </p:sp>
-      <p:sp>
-        <p:nvSpPr>
-          <p:cNvPr id="59" name="Text 56"/>
-          <p:cNvSpPr/>
-          <p:nvPr/>
-        </p:nvSpPr>
-        <p:spPr>
-          <a:xfrm>
-            <a:off x="3872484" y="9006840"/>
-            <a:ext cx="3031236" cy="246888"/>
+              <a:t>Evidence of leadership behaviour under real load, not self-report.</a:t>
+            </a:r>
+            <a:endParaRPr lang="en-US" sz="840" dirty="0"/>
+          </a:p>
+        </p:txBody>
+      </p:sp>
+      <p:sp>
+        <p:nvSpPr>
+          <p:cNvPr id="54" name="Text 51"/>
+          <p:cNvSpPr/>
+          <p:nvPr/>
+        </p:nvSpPr>
+        <p:spPr>
+          <a:xfrm>
+            <a:off x="3872484" y="8577072"/>
+            <a:ext cx="3031236" cy="228600"/>
           </a:xfrm>
           <a:prstGeom prst="rect">
             <a:avLst/>
@@ -2999,7 +2808,7 @@
               <a:buChar char="•"/>
             </a:pPr>
             <a:r>
-              <a:rPr lang="en-US" sz="810" dirty="0">
+              <a:rPr lang="en-US" sz="840" dirty="0">
                 <a:solidFill>
                   <a:srgbClr val="000000"/>
                 </a:solidFill>
@@ -3007,22 +2816,22 @@
                 <a:ea typeface="Arial" pitchFamily="34" charset="-122"/>
                 <a:cs typeface="Arial" pitchFamily="34" charset="-120"/>
               </a:rPr>
-              <a:t>Each leader holds peer evidence of how their behaviour actually lands.</a:t>
-            </a:r>
-            <a:endParaRPr lang="en-US" sz="810" dirty="0"/>
-          </a:p>
-        </p:txBody>
-      </p:sp>
-      <p:sp>
-        <p:nvSpPr>
-          <p:cNvPr id="60" name="Text 57"/>
-          <p:cNvSpPr/>
-          <p:nvPr/>
-        </p:nvSpPr>
-        <p:spPr>
-          <a:xfrm>
-            <a:off x="658368" y="9272016"/>
-            <a:ext cx="3031236" cy="246888"/>
+              <a:t>Peer feedback on how each leader's behaviour affects others.</a:t>
+            </a:r>
+            <a:endParaRPr lang="en-US" sz="840" dirty="0"/>
+          </a:p>
+        </p:txBody>
+      </p:sp>
+      <p:sp>
+        <p:nvSpPr>
+          <p:cNvPr id="55" name="Text 52"/>
+          <p:cNvSpPr/>
+          <p:nvPr/>
+        </p:nvSpPr>
+        <p:spPr>
+          <a:xfrm>
+            <a:off x="658368" y="8823960"/>
+            <a:ext cx="3031236" cy="228600"/>
           </a:xfrm>
           <a:prstGeom prst="rect">
             <a:avLst/>
@@ -3039,7 +2848,7 @@
               <a:buChar char="•"/>
             </a:pPr>
             <a:r>
-              <a:rPr lang="en-US" sz="810" dirty="0">
+              <a:rPr lang="en-US" sz="840" dirty="0">
                 <a:solidFill>
                   <a:srgbClr val="000000"/>
                 </a:solidFill>
@@ -3047,22 +2856,22 @@
                 <a:ea typeface="Arial" pitchFamily="34" charset="-122"/>
                 <a:cs typeface="Arial" pitchFamily="34" charset="-120"/>
               </a:rPr>
-              <a:t>Every leader returns with a written plan for behavioural adaptation.</a:t>
-            </a:r>
-            <a:endParaRPr lang="en-US" sz="810" dirty="0"/>
-          </a:p>
-        </p:txBody>
-      </p:sp>
-      <p:sp>
-        <p:nvSpPr>
-          <p:cNvPr id="61" name="Text 58"/>
-          <p:cNvSpPr/>
-          <p:nvPr/>
-        </p:nvSpPr>
-        <p:spPr>
-          <a:xfrm>
-            <a:off x="3872484" y="9272016"/>
-            <a:ext cx="3031236" cy="246888"/>
+              <a:t>A written, observable plan for behavioural adaptation.</a:t>
+            </a:r>
+            <a:endParaRPr lang="en-US" sz="840" dirty="0"/>
+          </a:p>
+        </p:txBody>
+      </p:sp>
+      <p:sp>
+        <p:nvSpPr>
+          <p:cNvPr id="56" name="Text 53"/>
+          <p:cNvSpPr/>
+          <p:nvPr/>
+        </p:nvSpPr>
+        <p:spPr>
+          <a:xfrm>
+            <a:off x="3872484" y="8823960"/>
+            <a:ext cx="3031236" cy="228600"/>
           </a:xfrm>
           <a:prstGeom prst="rect">
             <a:avLst/>
@@ -3079,7 +2888,7 @@
               <a:buChar char="•"/>
             </a:pPr>
             <a:r>
-              <a:rPr lang="en-US" sz="810" dirty="0">
+              <a:rPr lang="en-US" sz="840" dirty="0">
                 <a:solidFill>
                   <a:srgbClr val="000000"/>
                 </a:solidFill>
@@ -3087,22 +2896,22 @@
                 <a:ea typeface="Arial" pitchFamily="34" charset="-122"/>
                 <a:cs typeface="Arial" pitchFamily="34" charset="-120"/>
               </a:rPr>
-              <a:t>Nested in the NZDF Leadership Framework, Lead Self to Lead Organisation.</a:t>
-            </a:r>
-            <a:endParaRPr lang="en-US" sz="810" dirty="0"/>
-          </a:p>
-        </p:txBody>
-      </p:sp>
-      <p:sp>
-        <p:nvSpPr>
-          <p:cNvPr id="62" name="Shape 59"/>
-          <p:cNvSpPr/>
-          <p:nvPr/>
-        </p:nvSpPr>
-        <p:spPr>
-          <a:xfrm>
-            <a:off x="457200" y="9656064"/>
-            <a:ext cx="6647688" cy="493776"/>
+              <a:t>Alignment with the NZDF Leadership Framework, Lead Self to Lead Organisation.</a:t>
+            </a:r>
+            <a:endParaRPr lang="en-US" sz="840" dirty="0"/>
+          </a:p>
+        </p:txBody>
+      </p:sp>
+      <p:sp>
+        <p:nvSpPr>
+          <p:cNvPr id="57" name="Shape 54"/>
+          <p:cNvSpPr/>
+          <p:nvPr/>
+        </p:nvSpPr>
+        <p:spPr>
+          <a:xfrm>
+            <a:off x="457200" y="9363456"/>
+            <a:ext cx="6647688" cy="384048"/>
           </a:xfrm>
           <a:prstGeom prst="rect">
             <a:avLst/>
@@ -3120,13 +2929,13 @@
       </p:sp>
       <p:sp>
         <p:nvSpPr>
-          <p:cNvPr id="63" name="Text 60"/>
-          <p:cNvSpPr/>
-          <p:nvPr/>
-        </p:nvSpPr>
-        <p:spPr>
-          <a:xfrm>
-            <a:off x="621792" y="9720072"/>
+          <p:cNvPr id="58" name="Text 55"/>
+          <p:cNvSpPr/>
+          <p:nvPr/>
+        </p:nvSpPr>
+        <p:spPr>
+          <a:xfrm>
+            <a:off x="621792" y="9363456"/>
             <a:ext cx="6318504" cy="384048"/>
           </a:xfrm>
           <a:prstGeom prst="rect">
@@ -3136,7 +2945,7 @@
           <a:ln/>
         </p:spPr>
         <p:txBody>
-          <a:bodyPr wrap="square" lIns="0" tIns="0" rIns="0" bIns="0" rtlCol="0" anchor="t"/>
+          <a:bodyPr wrap="square" lIns="0" tIns="0" rIns="0" bIns="0" rtlCol="0" anchor="ctr"/>
           <a:lstStyle/>
           <a:p>
             <a:pPr algn="l" indent="0" marL="0">
@@ -3146,7 +2955,7 @@
               <a:buNone/>
             </a:pPr>
             <a:r>
-              <a:rPr lang="en-US" sz="820" b="1" spc="60" kern="0" dirty="0">
+              <a:rPr lang="en-US" sz="840" b="1" spc="60" kern="0" dirty="0">
                 <a:solidFill>
                   <a:srgbClr val="002516"/>
                 </a:solidFill>
@@ -3154,7 +2963,7 @@
                 <a:ea typeface="Arial" pitchFamily="34" charset="-122"/>
                 <a:cs typeface="Arial" pitchFamily="34" charset="-120"/>
               </a:rPr>
-              <a:t>DELIVERED BY THE NZ ARMY LEADERSHIP CENTRE.  </a:t>
+              <a:t>DELIVERED BY NZALC.  </a:t>
             </a:r>
             <a:pPr algn="l" indent="0" marL="0">
               <a:lnSpc>
@@ -3163,7 +2972,7 @@
               <a:buNone/>
             </a:pPr>
             <a:r>
-              <a:rPr lang="en-US" sz="820" dirty="0">
+              <a:rPr lang="en-US" sz="840" dirty="0">
                 <a:solidFill>
                   <a:srgbClr val="000000"/>
                 </a:solidFill>
@@ -3171,22 +2980,22 @@
                 <a:ea typeface="Arial" pitchFamily="34" charset="-122"/>
                 <a:cs typeface="Arial" pitchFamily="34" charset="-120"/>
               </a:rPr>
-              <a:t>ELDA Command is developed and delivered by the NZ Army Leadership Centre as part of the Army Command School. It integrates validated psychometrics, evidence-based performance psychology and experiential leadership development within the NZDF Leadership Framework.</a:t>
-            </a:r>
-            <a:endParaRPr lang="en-US" sz="820" dirty="0"/>
-          </a:p>
-        </p:txBody>
-      </p:sp>
-      <p:sp>
-        <p:nvSpPr>
-          <p:cNvPr id="64" name="Text 61"/>
-          <p:cNvSpPr/>
-          <p:nvPr/>
-        </p:nvSpPr>
-        <p:spPr>
-          <a:xfrm>
-            <a:off x="457200" y="10222992"/>
-            <a:ext cx="6647688" cy="310896"/>
+              <a:t>ELDA Command is delivered by the NZ Army Leadership Centre as part of the Army Command School, integrating validated psychometrics, performance psychology and experiential leadership development.</a:t>
+            </a:r>
+            <a:endParaRPr lang="en-US" sz="840" dirty="0"/>
+          </a:p>
+        </p:txBody>
+      </p:sp>
+      <p:sp>
+        <p:nvSpPr>
+          <p:cNvPr id="59" name="Text 56"/>
+          <p:cNvSpPr/>
+          <p:nvPr/>
+        </p:nvSpPr>
+        <p:spPr>
+          <a:xfrm>
+            <a:off x="457200" y="9966960"/>
+            <a:ext cx="6647688" cy="292608"/>
           </a:xfrm>
           <a:prstGeom prst="rect">
             <a:avLst/>
@@ -3205,7 +3014,7 @@
               <a:buNone/>
             </a:pPr>
             <a:r>
-              <a:rPr lang="en-US" sz="860" dirty="0">
+              <a:rPr lang="en-US" sz="880" dirty="0">
                 <a:solidFill>
                   <a:srgbClr val="000000"/>
                 </a:solidFill>
@@ -3213,9 +3022,9 @@
                 <a:ea typeface="Arial" pitchFamily="34" charset="-122"/>
                 <a:cs typeface="Arial" pitchFamily="34" charset="-120"/>
               </a:rPr>
-              <a:t>NZALC welcomes the opportunity to tailor an ELDA Command serial to 2nd Commando Regiment's operational context and leadership priorities. Initial scoping would confirm participant profile, activity design, delivery model and support requirements.</a:t>
-            </a:r>
-            <a:endParaRPr lang="en-US" sz="860" dirty="0"/>
+              <a:t>NZALC can tailor a 2027 ELDA Command serial to 2nd Commando Regiment. Initial scoping would confirm participant profile, activity design, delivery model and support requirements.</a:t>
+            </a:r>
+            <a:endParaRPr lang="en-US" sz="880" dirty="0"/>
           </a:p>
         </p:txBody>
       </p:sp>

</xml_diff>

<commit_message>
Final presentation pass on the ELDA one-pager
Shortens the four unit-return points so each fits a single line, giving a
balanced two by two grid. The closing sentence becomes a labelled next
step rather than residual body copy, and the leadership fundamentals row
loses several words while keeping its categories.

Co-Authored-By: Claude Fable 5 <noreply@anthropic.com>
Claude-Session: https://claude.ai/code/session_01YLo1WfwUDkbwfJEF3ZNVbB
</commit_message>
<xml_diff>
--- a/output/elda-command-onepager.pptx
+++ b/output/elda-command-onepager.pptx
@@ -2269,7 +2269,7 @@
                 <a:ea typeface="Arial" pitchFamily="34" charset="-122"/>
                 <a:cs typeface="Arial" pitchFamily="34" charset="-120"/>
               </a:rPr>
-              <a:t>Command, management and leadership; the four pillars of trust; identity against reputation; and the four competency domains.</a:t>
+              <a:t>Command, management and leadership; trust; identity and reputation; and the four competency domains.</a:t>
             </a:r>
             <a:endParaRPr lang="en-US" sz="840" dirty="0"/>
           </a:p>
@@ -2688,11 +2688,11 @@
         <p:spPr>
           <a:xfrm>
             <a:off x="457200" y="8284464"/>
-            <a:ext cx="6647688" cy="804672"/>
+            <a:ext cx="6647688" cy="731520"/>
           </a:xfrm>
           <a:prstGeom prst="roundRect">
             <a:avLst>
-              <a:gd name="adj" fmla="val 6818"/>
+              <a:gd name="adj" fmla="val 7500"/>
             </a:avLst>
           </a:prstGeom>
           <a:solidFill>
@@ -2750,8 +2750,8 @@
         </p:nvSpPr>
         <p:spPr>
           <a:xfrm>
-            <a:off x="658368" y="8577072"/>
-            <a:ext cx="3031236" cy="228600"/>
+            <a:off x="658368" y="8595360"/>
+            <a:ext cx="3031236" cy="201168"/>
           </a:xfrm>
           <a:prstGeom prst="rect">
             <a:avLst/>
@@ -2776,7 +2776,7 @@
                 <a:ea typeface="Arial" pitchFamily="34" charset="-122"/>
                 <a:cs typeface="Arial" pitchFamily="34" charset="-120"/>
               </a:rPr>
-              <a:t>Evidence of leadership behaviour under real load, not self-report.</a:t>
+              <a:t>Leadership behaviour evidenced under real load.</a:t>
             </a:r>
             <a:endParaRPr lang="en-US" sz="840" dirty="0"/>
           </a:p>
@@ -2790,8 +2790,8 @@
         </p:nvSpPr>
         <p:spPr>
           <a:xfrm>
-            <a:off x="3872484" y="8577072"/>
-            <a:ext cx="3031236" cy="228600"/>
+            <a:off x="3872484" y="8595360"/>
+            <a:ext cx="3031236" cy="201168"/>
           </a:xfrm>
           <a:prstGeom prst="rect">
             <a:avLst/>
@@ -2816,7 +2816,7 @@
                 <a:ea typeface="Arial" pitchFamily="34" charset="-122"/>
                 <a:cs typeface="Arial" pitchFamily="34" charset="-120"/>
               </a:rPr>
-              <a:t>Peer feedback on how each leader's behaviour affects others.</a:t>
+              <a:t>Peer feedback on how each leader affects others.</a:t>
             </a:r>
             <a:endParaRPr lang="en-US" sz="840" dirty="0"/>
           </a:p>
@@ -2830,8 +2830,8 @@
         </p:nvSpPr>
         <p:spPr>
           <a:xfrm>
-            <a:off x="658368" y="8823960"/>
-            <a:ext cx="3031236" cy="228600"/>
+            <a:off x="658368" y="8814816"/>
+            <a:ext cx="3031236" cy="201168"/>
           </a:xfrm>
           <a:prstGeom prst="rect">
             <a:avLst/>
@@ -2856,7 +2856,7 @@
                 <a:ea typeface="Arial" pitchFamily="34" charset="-122"/>
                 <a:cs typeface="Arial" pitchFamily="34" charset="-120"/>
               </a:rPr>
-              <a:t>A written, observable plan for behavioural adaptation.</a:t>
+              <a:t>A written plan for behavioural adaptation.</a:t>
             </a:r>
             <a:endParaRPr lang="en-US" sz="840" dirty="0"/>
           </a:p>
@@ -2870,8 +2870,8 @@
         </p:nvSpPr>
         <p:spPr>
           <a:xfrm>
-            <a:off x="3872484" y="8823960"/>
-            <a:ext cx="3031236" cy="228600"/>
+            <a:off x="3872484" y="8814816"/>
+            <a:ext cx="3031236" cy="201168"/>
           </a:xfrm>
           <a:prstGeom prst="rect">
             <a:avLst/>
@@ -2896,7 +2896,7 @@
                 <a:ea typeface="Arial" pitchFamily="34" charset="-122"/>
                 <a:cs typeface="Arial" pitchFamily="34" charset="-120"/>
               </a:rPr>
-              <a:t>Alignment with the NZDF Leadership Framework, Lead Self to Lead Organisation.</a:t>
+              <a:t>Alignment with the NZDF Leadership Framework.</a:t>
             </a:r>
             <a:endParaRPr lang="en-US" sz="840" dirty="0"/>
           </a:p>
@@ -2994,7 +2994,46 @@
         </p:nvSpPr>
         <p:spPr>
           <a:xfrm>
-            <a:off x="457200" y="9966960"/>
+            <a:off x="457200" y="9930384"/>
+            <a:ext cx="6647688" cy="182880"/>
+          </a:xfrm>
+          <a:prstGeom prst="rect">
+            <a:avLst/>
+          </a:prstGeom>
+          <a:noFill/>
+          <a:ln/>
+        </p:spPr>
+        <p:txBody>
+          <a:bodyPr wrap="square" lIns="0" tIns="0" rIns="0" bIns="0" rtlCol="0" anchor="ctr"/>
+          <a:lstStyle/>
+          <a:p>
+            <a:pPr algn="l" indent="0" marL="0">
+              <a:buNone/>
+            </a:pPr>
+            <a:r>
+              <a:rPr lang="en-US" sz="850" b="1" spc="140" kern="0" dirty="0">
+                <a:solidFill>
+                  <a:srgbClr val="002516"/>
+                </a:solidFill>
+                <a:latin typeface="Arial" pitchFamily="34" charset="0"/>
+                <a:ea typeface="Arial" pitchFamily="34" charset="-122"/>
+                <a:cs typeface="Arial" pitchFamily="34" charset="-120"/>
+              </a:rPr>
+              <a:t>NEXT STEP</a:t>
+            </a:r>
+            <a:endParaRPr lang="en-US" sz="850" dirty="0"/>
+          </a:p>
+        </p:txBody>
+      </p:sp>
+      <p:sp>
+        <p:nvSpPr>
+          <p:cNvPr id="60" name="Text 57"/>
+          <p:cNvSpPr/>
+          <p:nvPr/>
+        </p:nvSpPr>
+        <p:spPr>
+          <a:xfrm>
+            <a:off x="457200" y="10131552"/>
             <a:ext cx="6647688" cy="292608"/>
           </a:xfrm>
           <a:prstGeom prst="rect">
@@ -3022,7 +3061,7 @@
                 <a:ea typeface="Arial" pitchFamily="34" charset="-122"/>
                 <a:cs typeface="Arial" pitchFamily="34" charset="-120"/>
               </a:rPr>
-              <a:t>NZALC can tailor a 2027 ELDA Command serial to 2nd Commando Regiment. Initial scoping would confirm participant profile, activity design, delivery model and support requirements.</a:t>
+              <a:t>Scope a tailored 2027 ELDA Command serial for 2nd Commando Regiment, confirming participant profile, activity design, delivery model and support requirements.</a:t>
             </a:r>
             <a:endParaRPr lang="en-US" sz="880" dirty="0"/>
           </a:p>

</xml_diff>

<commit_message>
Editorial fixes: hyphenate Five-Factor, capitalise Keep, Stop, Start
Standardises the named method as Keep, Stop, Start in both the recover
phase and the Leadership Development Plan entry.

Co-Authored-By: Claude Fable 5 <noreply@anthropic.com>
Claude-Session: https://claude.ai/code/session_01YLo1WfwUDkbwfJEF3ZNVbB
</commit_message>
<xml_diff>
--- a/output/elda-command-onepager.pptx
+++ b/output/elda-command-onepager.pptx
@@ -2129,7 +2129,7 @@
                 <a:ea typeface="Arial" pitchFamily="34" charset="-122"/>
                 <a:cs typeface="Arial" pitchFamily="34" charset="-120"/>
               </a:rPr>
-              <a:t>Build a Leadership Development Plan and keep, stop, start Game Plan.</a:t>
+              <a:t>Build a Leadership Development Plan and Keep, Stop, Start Game Plan.</a:t>
             </a:r>
             <a:endParaRPr lang="en-US" sz="820" dirty="0"/>
           </a:p>
@@ -2370,7 +2370,7 @@
                 <a:ea typeface="Arial" pitchFamily="34" charset="-122"/>
                 <a:cs typeface="Arial" pitchFamily="34" charset="-120"/>
               </a:rPr>
-              <a:t>A validated Five Factor profile of everyday behaviour, behaviour under pressure, and underlying needs and drivers.</a:t>
+              <a:t>A validated Five-Factor profile of everyday behaviour, behaviour under pressure, and underlying needs and drivers.</a:t>
             </a:r>
             <a:endParaRPr lang="en-US" sz="840" dirty="0"/>
           </a:p>
@@ -2673,7 +2673,7 @@
                 <a:ea typeface="Arial" pitchFamily="34" charset="-122"/>
                 <a:cs typeface="Arial" pitchFamily="34" charset="-120"/>
               </a:rPr>
-              <a:t>Three behaviours to sustain and three to adapt, converted into observable keep, stop and start actions.</a:t>
+              <a:t>Three behaviours to sustain and three to adapt, converted into observable Keep, Stop, Start actions.</a:t>
             </a:r>
             <a:endParaRPr lang="en-US" sz="840" dirty="0"/>
           </a:p>

</xml_diff>